<commit_message>
style: convert slide deck to clean white background theme
</commit_message>
<xml_diff>
--- a/slide_thuyet_trinh_QuizAI_final.pptx
+++ b/slide_thuyet_trinh_QuizAI_final.pptx
@@ -3119,7 +3119,7 @@
             <a:avLst/>
           </a:prstGeom>
           <a:solidFill>
-            <a:srgbClr val="0B0F19"/>
+            <a:srgbClr val="FFFFFF"/>
           </a:solidFill>
           <a:ln>
             <a:noFill/>
@@ -3162,7 +3162,7 @@
             <a:avLst/>
           </a:prstGeom>
           <a:solidFill>
-            <a:srgbClr val="6366F1"/>
+            <a:srgbClr val="4338CA"/>
           </a:solidFill>
           <a:ln>
             <a:noFill/>
@@ -3205,11 +3205,11 @@
             <a:avLst/>
           </a:prstGeom>
           <a:solidFill>
-            <a:srgbClr val="131B2E"/>
+            <a:srgbClr val="F8FAFC"/>
           </a:solidFill>
           <a:ln w="19050">
             <a:solidFill>
-              <a:srgbClr val="283554"/>
+              <a:srgbClr val="E2E8F0"/>
             </a:solidFill>
           </a:ln>
         </p:spPr>
@@ -3263,7 +3263,7 @@
               </a:spcAft>
               <a:defRPr sz="1200" b="1">
                 <a:solidFill>
-                  <a:srgbClr val="06B6D4"/>
+                  <a:srgbClr val="4338CA"/>
                 </a:solidFill>
                 <a:latin typeface="Segoe UI"/>
               </a:defRPr>
@@ -3279,7 +3279,7 @@
               </a:spcAft>
               <a:defRPr sz="2800" b="1">
                 <a:solidFill>
-                  <a:srgbClr val="FFFFFF"/>
+                  <a:srgbClr val="0F172A"/>
                 </a:solidFill>
                 <a:latin typeface="Segoe UI"/>
               </a:defRPr>
@@ -3299,7 +3299,7 @@
               </a:spcAft>
               <a:defRPr sz="1400">
                 <a:solidFill>
-                  <a:srgbClr val="CBD5E1"/>
+                  <a:srgbClr val="334155"/>
                 </a:solidFill>
                 <a:latin typeface="Segoe UI"/>
               </a:defRPr>
@@ -3312,7 +3312,7 @@
             <a:pPr algn="ctr">
               <a:defRPr sz="1300" b="1">
                 <a:solidFill>
-                  <a:srgbClr val="94A3B8"/>
+                  <a:srgbClr val="64748B"/>
                 </a:solidFill>
                 <a:latin typeface="Segoe UI"/>
               </a:defRPr>
@@ -3356,7 +3356,7 @@
             <a:avLst/>
           </a:prstGeom>
           <a:solidFill>
-            <a:srgbClr val="0B0F19"/>
+            <a:srgbClr val="FFFFFF"/>
           </a:solidFill>
           <a:ln>
             <a:noFill/>
@@ -3399,7 +3399,7 @@
             <a:avLst/>
           </a:prstGeom>
           <a:solidFill>
-            <a:srgbClr val="6366F1"/>
+            <a:srgbClr val="4338CA"/>
           </a:solidFill>
           <a:ln>
             <a:noFill/>
@@ -3455,7 +3455,7 @@
               </a:spcAft>
               <a:defRPr sz="1100" b="1">
                 <a:solidFill>
-                  <a:srgbClr val="06B6D4"/>
+                  <a:srgbClr val="4338CA"/>
                 </a:solidFill>
                 <a:latin typeface="Segoe UI"/>
               </a:defRPr>
@@ -3471,7 +3471,7 @@
               </a:spcAft>
               <a:defRPr sz="2200" b="1">
                 <a:solidFill>
-                  <a:srgbClr val="FFFFFF"/>
+                  <a:srgbClr val="0F172A"/>
                 </a:solidFill>
                 <a:latin typeface="Segoe UI"/>
               </a:defRPr>
@@ -3484,7 +3484,7 @@
             <a:pPr>
               <a:defRPr sz="1300">
                 <a:solidFill>
-                  <a:srgbClr val="94A3B8"/>
+                  <a:srgbClr val="64748B"/>
                 </a:solidFill>
                 <a:latin typeface="Segoe UI"/>
               </a:defRPr>
@@ -3510,11 +3510,11 @@
             <a:avLst/>
           </a:prstGeom>
           <a:solidFill>
-            <a:srgbClr val="131B2E"/>
+            <a:srgbClr val="F8FAFC"/>
           </a:solidFill>
-          <a:ln w="12700">
+          <a:ln w="15240">
             <a:solidFill>
-              <a:srgbClr val="283554"/>
+              <a:srgbClr val="E2E8F0"/>
             </a:solidFill>
           </a:ln>
         </p:spPr>
@@ -3565,7 +3565,7 @@
             <a:pPr>
               <a:defRPr sz="1500" b="1">
                 <a:solidFill>
-                  <a:srgbClr val="06B6D4"/>
+                  <a:srgbClr val="0369A1"/>
                 </a:solidFill>
                 <a:latin typeface="Segoe UI"/>
               </a:defRPr>
@@ -3604,7 +3604,7 @@
               </a:spcAft>
               <a:defRPr sz="1300">
                 <a:solidFill>
-                  <a:srgbClr val="CBD5E1"/>
+                  <a:srgbClr val="334155"/>
                 </a:solidFill>
                 <a:latin typeface="Segoe UI"/>
               </a:defRPr>
@@ -3620,7 +3620,7 @@
               </a:spcAft>
               <a:defRPr sz="1300">
                 <a:solidFill>
-                  <a:srgbClr val="CBD5E1"/>
+                  <a:srgbClr val="334155"/>
                 </a:solidFill>
                 <a:latin typeface="Segoe UI"/>
               </a:defRPr>
@@ -3636,7 +3636,7 @@
               </a:spcAft>
               <a:defRPr sz="1300">
                 <a:solidFill>
-                  <a:srgbClr val="CBD5E1"/>
+                  <a:srgbClr val="334155"/>
                 </a:solidFill>
                 <a:latin typeface="Segoe UI"/>
               </a:defRPr>
@@ -3652,7 +3652,7 @@
               </a:spcAft>
               <a:defRPr sz="1300">
                 <a:solidFill>
-                  <a:srgbClr val="CBD5E1"/>
+                  <a:srgbClr val="334155"/>
                 </a:solidFill>
                 <a:latin typeface="Segoe UI"/>
               </a:defRPr>
@@ -3668,7 +3668,7 @@
               </a:spcAft>
               <a:defRPr sz="1300">
                 <a:solidFill>
-                  <a:srgbClr val="CBD5E1"/>
+                  <a:srgbClr val="334155"/>
                 </a:solidFill>
                 <a:latin typeface="Segoe UI"/>
               </a:defRPr>
@@ -3694,11 +3694,11 @@
             <a:avLst/>
           </a:prstGeom>
           <a:solidFill>
-            <a:srgbClr val="131B2E"/>
+            <a:srgbClr val="F8FAFC"/>
           </a:solidFill>
-          <a:ln w="12700">
+          <a:ln w="15240">
             <a:solidFill>
-              <a:srgbClr val="283554"/>
+              <a:srgbClr val="E2E8F0"/>
             </a:solidFill>
           </a:ln>
         </p:spPr>
@@ -3749,7 +3749,7 @@
             <a:pPr>
               <a:defRPr sz="1500" b="1">
                 <a:solidFill>
-                  <a:srgbClr val="6366F1"/>
+                  <a:srgbClr val="4338CA"/>
                 </a:solidFill>
                 <a:latin typeface="Segoe UI"/>
               </a:defRPr>
@@ -3788,7 +3788,7 @@
               </a:spcAft>
               <a:defRPr sz="1300">
                 <a:solidFill>
-                  <a:srgbClr val="CBD5E1"/>
+                  <a:srgbClr val="334155"/>
                 </a:solidFill>
                 <a:latin typeface="Segoe UI"/>
               </a:defRPr>
@@ -3804,7 +3804,7 @@
               </a:spcAft>
               <a:defRPr sz="1300">
                 <a:solidFill>
-                  <a:srgbClr val="CBD5E1"/>
+                  <a:srgbClr val="334155"/>
                 </a:solidFill>
                 <a:latin typeface="Segoe UI"/>
               </a:defRPr>
@@ -3820,7 +3820,7 @@
               </a:spcAft>
               <a:defRPr sz="1300">
                 <a:solidFill>
-                  <a:srgbClr val="CBD5E1"/>
+                  <a:srgbClr val="334155"/>
                 </a:solidFill>
                 <a:latin typeface="Segoe UI"/>
               </a:defRPr>
@@ -3836,7 +3836,7 @@
               </a:spcAft>
               <a:defRPr sz="1300">
                 <a:solidFill>
-                  <a:srgbClr val="CBD5E1"/>
+                  <a:srgbClr val="334155"/>
                 </a:solidFill>
                 <a:latin typeface="Segoe UI"/>
               </a:defRPr>
@@ -3852,7 +3852,7 @@
               </a:spcAft>
               <a:defRPr sz="1300">
                 <a:solidFill>
-                  <a:srgbClr val="CBD5E1"/>
+                  <a:srgbClr val="334155"/>
                 </a:solidFill>
                 <a:latin typeface="Segoe UI"/>
               </a:defRPr>
@@ -3896,7 +3896,7 @@
             <a:avLst/>
           </a:prstGeom>
           <a:solidFill>
-            <a:srgbClr val="0B0F19"/>
+            <a:srgbClr val="FFFFFF"/>
           </a:solidFill>
           <a:ln>
             <a:noFill/>
@@ -3939,7 +3939,7 @@
             <a:avLst/>
           </a:prstGeom>
           <a:solidFill>
-            <a:srgbClr val="6366F1"/>
+            <a:srgbClr val="4338CA"/>
           </a:solidFill>
           <a:ln>
             <a:noFill/>
@@ -3995,7 +3995,7 @@
               </a:spcAft>
               <a:defRPr sz="1100" b="1">
                 <a:solidFill>
-                  <a:srgbClr val="06B6D4"/>
+                  <a:srgbClr val="4338CA"/>
                 </a:solidFill>
                 <a:latin typeface="Segoe UI"/>
               </a:defRPr>
@@ -4011,7 +4011,7 @@
               </a:spcAft>
               <a:defRPr sz="2200" b="1">
                 <a:solidFill>
-                  <a:srgbClr val="FFFFFF"/>
+                  <a:srgbClr val="0F172A"/>
                 </a:solidFill>
                 <a:latin typeface="Segoe UI"/>
               </a:defRPr>
@@ -4024,7 +4024,7 @@
             <a:pPr>
               <a:defRPr sz="1300">
                 <a:solidFill>
-                  <a:srgbClr val="94A3B8"/>
+                  <a:srgbClr val="64748B"/>
                 </a:solidFill>
                 <a:latin typeface="Segoe UI"/>
               </a:defRPr>
@@ -4050,11 +4050,11 @@
             <a:avLst/>
           </a:prstGeom>
           <a:solidFill>
-            <a:srgbClr val="131B2E"/>
+            <a:srgbClr val="F8FAFC"/>
           </a:solidFill>
-          <a:ln w="12700">
+          <a:ln w="15240">
             <a:solidFill>
-              <a:srgbClr val="283554"/>
+              <a:srgbClr val="E2E8F0"/>
             </a:solidFill>
           </a:ln>
         </p:spPr>
@@ -4105,7 +4105,7 @@
             <a:pPr>
               <a:defRPr sz="1500" b="1">
                 <a:solidFill>
-                  <a:srgbClr val="6366F1"/>
+                  <a:srgbClr val="4338CA"/>
                 </a:solidFill>
                 <a:latin typeface="Segoe UI"/>
               </a:defRPr>
@@ -4144,7 +4144,7 @@
               </a:spcAft>
               <a:defRPr sz="1300">
                 <a:solidFill>
-                  <a:srgbClr val="CBD5E1"/>
+                  <a:srgbClr val="334155"/>
                 </a:solidFill>
                 <a:latin typeface="Segoe UI"/>
               </a:defRPr>
@@ -4160,7 +4160,7 @@
               </a:spcAft>
               <a:defRPr sz="1300">
                 <a:solidFill>
-                  <a:srgbClr val="CBD5E1"/>
+                  <a:srgbClr val="334155"/>
                 </a:solidFill>
                 <a:latin typeface="Segoe UI"/>
               </a:defRPr>
@@ -4176,7 +4176,7 @@
               </a:spcAft>
               <a:defRPr sz="1300">
                 <a:solidFill>
-                  <a:srgbClr val="CBD5E1"/>
+                  <a:srgbClr val="334155"/>
                 </a:solidFill>
                 <a:latin typeface="Segoe UI"/>
               </a:defRPr>
@@ -4192,7 +4192,7 @@
               </a:spcAft>
               <a:defRPr sz="1300">
                 <a:solidFill>
-                  <a:srgbClr val="CBD5E1"/>
+                  <a:srgbClr val="334155"/>
                 </a:solidFill>
                 <a:latin typeface="Segoe UI"/>
               </a:defRPr>
@@ -4208,7 +4208,7 @@
               </a:spcAft>
               <a:defRPr sz="1300">
                 <a:solidFill>
-                  <a:srgbClr val="CBD5E1"/>
+                  <a:srgbClr val="334155"/>
                 </a:solidFill>
                 <a:latin typeface="Segoe UI"/>
               </a:defRPr>
@@ -4234,11 +4234,11 @@
             <a:avLst/>
           </a:prstGeom>
           <a:solidFill>
-            <a:srgbClr val="131B2E"/>
+            <a:srgbClr val="F8FAFC"/>
           </a:solidFill>
-          <a:ln w="12700">
+          <a:ln w="15240">
             <a:solidFill>
-              <a:srgbClr val="283554"/>
+              <a:srgbClr val="E2E8F0"/>
             </a:solidFill>
           </a:ln>
         </p:spPr>
@@ -4289,7 +4289,7 @@
             <a:pPr>
               <a:defRPr sz="1500" b="1">
                 <a:solidFill>
-                  <a:srgbClr val="10B981"/>
+                  <a:srgbClr val="047857"/>
                 </a:solidFill>
                 <a:latin typeface="Segoe UI"/>
               </a:defRPr>
@@ -4328,7 +4328,7 @@
               </a:spcAft>
               <a:defRPr sz="1300">
                 <a:solidFill>
-                  <a:srgbClr val="CBD5E1"/>
+                  <a:srgbClr val="334155"/>
                 </a:solidFill>
                 <a:latin typeface="Segoe UI"/>
               </a:defRPr>
@@ -4344,7 +4344,7 @@
               </a:spcAft>
               <a:defRPr sz="1300">
                 <a:solidFill>
-                  <a:srgbClr val="CBD5E1"/>
+                  <a:srgbClr val="334155"/>
                 </a:solidFill>
                 <a:latin typeface="Segoe UI"/>
               </a:defRPr>
@@ -4360,7 +4360,7 @@
               </a:spcAft>
               <a:defRPr sz="1300">
                 <a:solidFill>
-                  <a:srgbClr val="CBD5E1"/>
+                  <a:srgbClr val="334155"/>
                 </a:solidFill>
                 <a:latin typeface="Segoe UI"/>
               </a:defRPr>
@@ -4376,7 +4376,7 @@
               </a:spcAft>
               <a:defRPr sz="1300">
                 <a:solidFill>
-                  <a:srgbClr val="CBD5E1"/>
+                  <a:srgbClr val="334155"/>
                 </a:solidFill>
                 <a:latin typeface="Segoe UI"/>
               </a:defRPr>
@@ -4392,7 +4392,7 @@
               </a:spcAft>
               <a:defRPr sz="1300">
                 <a:solidFill>
-                  <a:srgbClr val="CBD5E1"/>
+                  <a:srgbClr val="334155"/>
                 </a:solidFill>
                 <a:latin typeface="Segoe UI"/>
               </a:defRPr>
@@ -4436,7 +4436,7 @@
             <a:avLst/>
           </a:prstGeom>
           <a:solidFill>
-            <a:srgbClr val="0B0F19"/>
+            <a:srgbClr val="FFFFFF"/>
           </a:solidFill>
           <a:ln>
             <a:noFill/>
@@ -4479,7 +4479,7 @@
             <a:avLst/>
           </a:prstGeom>
           <a:solidFill>
-            <a:srgbClr val="6366F1"/>
+            <a:srgbClr val="4338CA"/>
           </a:solidFill>
           <a:ln>
             <a:noFill/>
@@ -4535,7 +4535,7 @@
               </a:spcAft>
               <a:defRPr sz="1100" b="1">
                 <a:solidFill>
-                  <a:srgbClr val="06B6D4"/>
+                  <a:srgbClr val="4338CA"/>
                 </a:solidFill>
                 <a:latin typeface="Segoe UI"/>
               </a:defRPr>
@@ -4551,7 +4551,7 @@
               </a:spcAft>
               <a:defRPr sz="2200" b="1">
                 <a:solidFill>
-                  <a:srgbClr val="FFFFFF"/>
+                  <a:srgbClr val="0F172A"/>
                 </a:solidFill>
                 <a:latin typeface="Segoe UI"/>
               </a:defRPr>
@@ -4564,7 +4564,7 @@
             <a:pPr>
               <a:defRPr sz="1300">
                 <a:solidFill>
-                  <a:srgbClr val="94A3B8"/>
+                  <a:srgbClr val="64748B"/>
                 </a:solidFill>
                 <a:latin typeface="Segoe UI"/>
               </a:defRPr>
@@ -4590,11 +4590,11 @@
             <a:avLst/>
           </a:prstGeom>
           <a:solidFill>
-            <a:srgbClr val="131B2E"/>
+            <a:srgbClr val="F8FAFC"/>
           </a:solidFill>
-          <a:ln w="12700">
+          <a:ln w="15240">
             <a:solidFill>
-              <a:srgbClr val="283554"/>
+              <a:srgbClr val="E2E8F0"/>
             </a:solidFill>
           </a:ln>
         </p:spPr>
@@ -4645,7 +4645,7 @@
             <a:pPr>
               <a:defRPr sz="1500" b="1">
                 <a:solidFill>
-                  <a:srgbClr val="06B6D4"/>
+                  <a:srgbClr val="0369A1"/>
                 </a:solidFill>
                 <a:latin typeface="Segoe UI"/>
               </a:defRPr>
@@ -4684,7 +4684,7 @@
               </a:spcAft>
               <a:defRPr sz="1300">
                 <a:solidFill>
-                  <a:srgbClr val="CBD5E1"/>
+                  <a:srgbClr val="334155"/>
                 </a:solidFill>
                 <a:latin typeface="Segoe UI"/>
               </a:defRPr>
@@ -4700,7 +4700,7 @@
               </a:spcAft>
               <a:defRPr sz="1300">
                 <a:solidFill>
-                  <a:srgbClr val="CBD5E1"/>
+                  <a:srgbClr val="334155"/>
                 </a:solidFill>
                 <a:latin typeface="Segoe UI"/>
               </a:defRPr>
@@ -4716,7 +4716,7 @@
               </a:spcAft>
               <a:defRPr sz="1300">
                 <a:solidFill>
-                  <a:srgbClr val="CBD5E1"/>
+                  <a:srgbClr val="334155"/>
                 </a:solidFill>
                 <a:latin typeface="Segoe UI"/>
               </a:defRPr>
@@ -4732,7 +4732,7 @@
               </a:spcAft>
               <a:defRPr sz="1300">
                 <a:solidFill>
-                  <a:srgbClr val="CBD5E1"/>
+                  <a:srgbClr val="334155"/>
                 </a:solidFill>
                 <a:latin typeface="Segoe UI"/>
               </a:defRPr>
@@ -4748,7 +4748,7 @@
               </a:spcAft>
               <a:defRPr sz="1300">
                 <a:solidFill>
-                  <a:srgbClr val="CBD5E1"/>
+                  <a:srgbClr val="334155"/>
                 </a:solidFill>
                 <a:latin typeface="Segoe UI"/>
               </a:defRPr>
@@ -4774,11 +4774,11 @@
             <a:avLst/>
           </a:prstGeom>
           <a:solidFill>
-            <a:srgbClr val="131B2E"/>
+            <a:srgbClr val="F8FAFC"/>
           </a:solidFill>
-          <a:ln w="12700">
+          <a:ln w="15240">
             <a:solidFill>
-              <a:srgbClr val="283554"/>
+              <a:srgbClr val="E2E8F0"/>
             </a:solidFill>
           </a:ln>
         </p:spPr>
@@ -4829,7 +4829,7 @@
             <a:pPr>
               <a:defRPr sz="1500" b="1">
                 <a:solidFill>
-                  <a:srgbClr val="F59E0B"/>
+                  <a:srgbClr val="B45309"/>
                 </a:solidFill>
                 <a:latin typeface="Segoe UI"/>
               </a:defRPr>
@@ -4868,7 +4868,7 @@
               </a:spcAft>
               <a:defRPr sz="1300">
                 <a:solidFill>
-                  <a:srgbClr val="CBD5E1"/>
+                  <a:srgbClr val="334155"/>
                 </a:solidFill>
                 <a:latin typeface="Segoe UI"/>
               </a:defRPr>
@@ -4884,7 +4884,7 @@
               </a:spcAft>
               <a:defRPr sz="1300">
                 <a:solidFill>
-                  <a:srgbClr val="CBD5E1"/>
+                  <a:srgbClr val="334155"/>
                 </a:solidFill>
                 <a:latin typeface="Segoe UI"/>
               </a:defRPr>
@@ -4900,7 +4900,7 @@
               </a:spcAft>
               <a:defRPr sz="1300">
                 <a:solidFill>
-                  <a:srgbClr val="CBD5E1"/>
+                  <a:srgbClr val="334155"/>
                 </a:solidFill>
                 <a:latin typeface="Segoe UI"/>
               </a:defRPr>
@@ -4916,7 +4916,7 @@
               </a:spcAft>
               <a:defRPr sz="1300">
                 <a:solidFill>
-                  <a:srgbClr val="CBD5E1"/>
+                  <a:srgbClr val="334155"/>
                 </a:solidFill>
                 <a:latin typeface="Segoe UI"/>
               </a:defRPr>
@@ -4932,7 +4932,7 @@
               </a:spcAft>
               <a:defRPr sz="1300">
                 <a:solidFill>
-                  <a:srgbClr val="CBD5E1"/>
+                  <a:srgbClr val="334155"/>
                 </a:solidFill>
                 <a:latin typeface="Segoe UI"/>
               </a:defRPr>
@@ -4976,7 +4976,7 @@
             <a:avLst/>
           </a:prstGeom>
           <a:solidFill>
-            <a:srgbClr val="0B0F19"/>
+            <a:srgbClr val="FFFFFF"/>
           </a:solidFill>
           <a:ln>
             <a:noFill/>
@@ -5019,7 +5019,7 @@
             <a:avLst/>
           </a:prstGeom>
           <a:solidFill>
-            <a:srgbClr val="6366F1"/>
+            <a:srgbClr val="4338CA"/>
           </a:solidFill>
           <a:ln>
             <a:noFill/>
@@ -5075,7 +5075,7 @@
               </a:spcAft>
               <a:defRPr sz="1100" b="1">
                 <a:solidFill>
-                  <a:srgbClr val="06B6D4"/>
+                  <a:srgbClr val="4338CA"/>
                 </a:solidFill>
                 <a:latin typeface="Segoe UI"/>
               </a:defRPr>
@@ -5091,7 +5091,7 @@
               </a:spcAft>
               <a:defRPr sz="2200" b="1">
                 <a:solidFill>
-                  <a:srgbClr val="FFFFFF"/>
+                  <a:srgbClr val="0F172A"/>
                 </a:solidFill>
                 <a:latin typeface="Segoe UI"/>
               </a:defRPr>
@@ -5104,7 +5104,7 @@
             <a:pPr>
               <a:defRPr sz="1300">
                 <a:solidFill>
-                  <a:srgbClr val="94A3B8"/>
+                  <a:srgbClr val="64748B"/>
                 </a:solidFill>
                 <a:latin typeface="Segoe UI"/>
               </a:defRPr>
@@ -5130,11 +5130,11 @@
             <a:avLst/>
           </a:prstGeom>
           <a:solidFill>
-            <a:srgbClr val="131B2E"/>
+            <a:srgbClr val="F8FAFC"/>
           </a:solidFill>
-          <a:ln w="12700">
+          <a:ln w="15240">
             <a:solidFill>
-              <a:srgbClr val="283554"/>
+              <a:srgbClr val="E2E8F0"/>
             </a:solidFill>
           </a:ln>
         </p:spPr>
@@ -5185,7 +5185,7 @@
             <a:pPr>
               <a:defRPr sz="1500" b="1">
                 <a:solidFill>
-                  <a:srgbClr val="EF4444"/>
+                  <a:srgbClr val="B91C1C"/>
                 </a:solidFill>
                 <a:latin typeface="Segoe UI"/>
               </a:defRPr>
@@ -5224,7 +5224,7 @@
               </a:spcAft>
               <a:defRPr sz="1300">
                 <a:solidFill>
-                  <a:srgbClr val="CBD5E1"/>
+                  <a:srgbClr val="334155"/>
                 </a:solidFill>
                 <a:latin typeface="Segoe UI"/>
               </a:defRPr>
@@ -5240,7 +5240,7 @@
               </a:spcAft>
               <a:defRPr sz="1300">
                 <a:solidFill>
-                  <a:srgbClr val="CBD5E1"/>
+                  <a:srgbClr val="334155"/>
                 </a:solidFill>
                 <a:latin typeface="Segoe UI"/>
               </a:defRPr>
@@ -5256,7 +5256,7 @@
               </a:spcAft>
               <a:defRPr sz="1300">
                 <a:solidFill>
-                  <a:srgbClr val="CBD5E1"/>
+                  <a:srgbClr val="334155"/>
                 </a:solidFill>
                 <a:latin typeface="Segoe UI"/>
               </a:defRPr>
@@ -5272,7 +5272,7 @@
               </a:spcAft>
               <a:defRPr sz="1300">
                 <a:solidFill>
-                  <a:srgbClr val="CBD5E1"/>
+                  <a:srgbClr val="334155"/>
                 </a:solidFill>
                 <a:latin typeface="Segoe UI"/>
               </a:defRPr>
@@ -5288,7 +5288,7 @@
               </a:spcAft>
               <a:defRPr sz="1300">
                 <a:solidFill>
-                  <a:srgbClr val="CBD5E1"/>
+                  <a:srgbClr val="334155"/>
                 </a:solidFill>
                 <a:latin typeface="Segoe UI"/>
               </a:defRPr>
@@ -5314,11 +5314,11 @@
             <a:avLst/>
           </a:prstGeom>
           <a:solidFill>
-            <a:srgbClr val="131B2E"/>
+            <a:srgbClr val="F8FAFC"/>
           </a:solidFill>
-          <a:ln w="12700">
+          <a:ln w="15240">
             <a:solidFill>
-              <a:srgbClr val="283554"/>
+              <a:srgbClr val="E2E8F0"/>
             </a:solidFill>
           </a:ln>
         </p:spPr>
@@ -5369,7 +5369,7 @@
             <a:pPr>
               <a:defRPr sz="1500" b="1">
                 <a:solidFill>
-                  <a:srgbClr val="F59E0B"/>
+                  <a:srgbClr val="B45309"/>
                 </a:solidFill>
                 <a:latin typeface="Segoe UI"/>
               </a:defRPr>
@@ -5408,7 +5408,7 @@
               </a:spcAft>
               <a:defRPr sz="1300">
                 <a:solidFill>
-                  <a:srgbClr val="CBD5E1"/>
+                  <a:srgbClr val="334155"/>
                 </a:solidFill>
                 <a:latin typeface="Segoe UI"/>
               </a:defRPr>
@@ -5424,7 +5424,7 @@
               </a:spcAft>
               <a:defRPr sz="1300">
                 <a:solidFill>
-                  <a:srgbClr val="CBD5E1"/>
+                  <a:srgbClr val="334155"/>
                 </a:solidFill>
                 <a:latin typeface="Segoe UI"/>
               </a:defRPr>
@@ -5440,7 +5440,7 @@
               </a:spcAft>
               <a:defRPr sz="1300">
                 <a:solidFill>
-                  <a:srgbClr val="CBD5E1"/>
+                  <a:srgbClr val="334155"/>
                 </a:solidFill>
                 <a:latin typeface="Segoe UI"/>
               </a:defRPr>
@@ -5456,7 +5456,7 @@
               </a:spcAft>
               <a:defRPr sz="1300">
                 <a:solidFill>
-                  <a:srgbClr val="CBD5E1"/>
+                  <a:srgbClr val="334155"/>
                 </a:solidFill>
                 <a:latin typeface="Segoe UI"/>
               </a:defRPr>
@@ -5472,7 +5472,7 @@
               </a:spcAft>
               <a:defRPr sz="1300">
                 <a:solidFill>
-                  <a:srgbClr val="CBD5E1"/>
+                  <a:srgbClr val="334155"/>
                 </a:solidFill>
                 <a:latin typeface="Segoe UI"/>
               </a:defRPr>
@@ -5498,11 +5498,11 @@
             <a:avLst/>
           </a:prstGeom>
           <a:solidFill>
-            <a:srgbClr val="131B2E"/>
+            <a:srgbClr val="F8FAFC"/>
           </a:solidFill>
-          <a:ln w="12700">
+          <a:ln w="15240">
             <a:solidFill>
-              <a:srgbClr val="283554"/>
+              <a:srgbClr val="E2E8F0"/>
             </a:solidFill>
           </a:ln>
         </p:spPr>
@@ -5553,7 +5553,7 @@
             <a:pPr>
               <a:defRPr sz="1500" b="1">
                 <a:solidFill>
-                  <a:srgbClr val="06B6D4"/>
+                  <a:srgbClr val="0369A1"/>
                 </a:solidFill>
                 <a:latin typeface="Segoe UI"/>
               </a:defRPr>
@@ -5592,7 +5592,7 @@
               </a:spcAft>
               <a:defRPr sz="1300">
                 <a:solidFill>
-                  <a:srgbClr val="CBD5E1"/>
+                  <a:srgbClr val="334155"/>
                 </a:solidFill>
                 <a:latin typeface="Segoe UI"/>
               </a:defRPr>
@@ -5608,7 +5608,7 @@
               </a:spcAft>
               <a:defRPr sz="1300">
                 <a:solidFill>
-                  <a:srgbClr val="CBD5E1"/>
+                  <a:srgbClr val="334155"/>
                 </a:solidFill>
                 <a:latin typeface="Segoe UI"/>
               </a:defRPr>
@@ -5624,7 +5624,7 @@
               </a:spcAft>
               <a:defRPr sz="1300">
                 <a:solidFill>
-                  <a:srgbClr val="CBD5E1"/>
+                  <a:srgbClr val="334155"/>
                 </a:solidFill>
                 <a:latin typeface="Segoe UI"/>
               </a:defRPr>
@@ -5640,7 +5640,7 @@
               </a:spcAft>
               <a:defRPr sz="1300">
                 <a:solidFill>
-                  <a:srgbClr val="CBD5E1"/>
+                  <a:srgbClr val="334155"/>
                 </a:solidFill>
                 <a:latin typeface="Segoe UI"/>
               </a:defRPr>
@@ -5656,7 +5656,7 @@
               </a:spcAft>
               <a:defRPr sz="1300">
                 <a:solidFill>
-                  <a:srgbClr val="CBD5E1"/>
+                  <a:srgbClr val="334155"/>
                 </a:solidFill>
                 <a:latin typeface="Segoe UI"/>
               </a:defRPr>
@@ -5700,7 +5700,7 @@
             <a:avLst/>
           </a:prstGeom>
           <a:solidFill>
-            <a:srgbClr val="0B0F19"/>
+            <a:srgbClr val="FFFFFF"/>
           </a:solidFill>
           <a:ln>
             <a:noFill/>
@@ -5743,7 +5743,7 @@
             <a:avLst/>
           </a:prstGeom>
           <a:solidFill>
-            <a:srgbClr val="6366F1"/>
+            <a:srgbClr val="4338CA"/>
           </a:solidFill>
           <a:ln>
             <a:noFill/>
@@ -5799,7 +5799,7 @@
               </a:spcAft>
               <a:defRPr sz="1100" b="1">
                 <a:solidFill>
-                  <a:srgbClr val="06B6D4"/>
+                  <a:srgbClr val="4338CA"/>
                 </a:solidFill>
                 <a:latin typeface="Segoe UI"/>
               </a:defRPr>
@@ -5815,7 +5815,7 @@
               </a:spcAft>
               <a:defRPr sz="2200" b="1">
                 <a:solidFill>
-                  <a:srgbClr val="FFFFFF"/>
+                  <a:srgbClr val="0F172A"/>
                 </a:solidFill>
                 <a:latin typeface="Segoe UI"/>
               </a:defRPr>
@@ -5828,7 +5828,7 @@
             <a:pPr>
               <a:defRPr sz="1300">
                 <a:solidFill>
-                  <a:srgbClr val="94A3B8"/>
+                  <a:srgbClr val="64748B"/>
                 </a:solidFill>
                 <a:latin typeface="Segoe UI"/>
               </a:defRPr>
@@ -5854,11 +5854,11 @@
             <a:avLst/>
           </a:prstGeom>
           <a:solidFill>
-            <a:srgbClr val="131B2E"/>
+            <a:srgbClr val="F8FAFC"/>
           </a:solidFill>
-          <a:ln w="12700">
+          <a:ln w="15240">
             <a:solidFill>
-              <a:srgbClr val="283554"/>
+              <a:srgbClr val="E2E8F0"/>
             </a:solidFill>
           </a:ln>
         </p:spPr>
@@ -5909,7 +5909,7 @@
             <a:pPr>
               <a:defRPr sz="1500" b="1">
                 <a:solidFill>
-                  <a:srgbClr val="6366F1"/>
+                  <a:srgbClr val="4338CA"/>
                 </a:solidFill>
                 <a:latin typeface="Segoe UI"/>
               </a:defRPr>
@@ -5948,7 +5948,7 @@
               </a:spcAft>
               <a:defRPr sz="1300">
                 <a:solidFill>
-                  <a:srgbClr val="CBD5E1"/>
+                  <a:srgbClr val="334155"/>
                 </a:solidFill>
                 <a:latin typeface="Segoe UI"/>
               </a:defRPr>
@@ -5964,7 +5964,7 @@
               </a:spcAft>
               <a:defRPr sz="1300">
                 <a:solidFill>
-                  <a:srgbClr val="CBD5E1"/>
+                  <a:srgbClr val="334155"/>
                 </a:solidFill>
                 <a:latin typeface="Segoe UI"/>
               </a:defRPr>
@@ -5980,7 +5980,7 @@
               </a:spcAft>
               <a:defRPr sz="1300">
                 <a:solidFill>
-                  <a:srgbClr val="CBD5E1"/>
+                  <a:srgbClr val="334155"/>
                 </a:solidFill>
                 <a:latin typeface="Segoe UI"/>
               </a:defRPr>
@@ -5996,7 +5996,7 @@
               </a:spcAft>
               <a:defRPr sz="1300">
                 <a:solidFill>
-                  <a:srgbClr val="CBD5E1"/>
+                  <a:srgbClr val="334155"/>
                 </a:solidFill>
                 <a:latin typeface="Segoe UI"/>
               </a:defRPr>
@@ -6012,7 +6012,7 @@
               </a:spcAft>
               <a:defRPr sz="1300">
                 <a:solidFill>
-                  <a:srgbClr val="CBD5E1"/>
+                  <a:srgbClr val="334155"/>
                 </a:solidFill>
                 <a:latin typeface="Segoe UI"/>
               </a:defRPr>
@@ -6038,11 +6038,11 @@
             <a:avLst/>
           </a:prstGeom>
           <a:solidFill>
-            <a:srgbClr val="131B2E"/>
+            <a:srgbClr val="F8FAFC"/>
           </a:solidFill>
-          <a:ln w="12700">
+          <a:ln w="15240">
             <a:solidFill>
-              <a:srgbClr val="283554"/>
+              <a:srgbClr val="E2E8F0"/>
             </a:solidFill>
           </a:ln>
         </p:spPr>
@@ -6093,7 +6093,7 @@
             <a:pPr>
               <a:defRPr sz="1500" b="1">
                 <a:solidFill>
-                  <a:srgbClr val="10B981"/>
+                  <a:srgbClr val="047857"/>
                 </a:solidFill>
                 <a:latin typeface="Segoe UI"/>
               </a:defRPr>
@@ -6132,7 +6132,7 @@
               </a:spcAft>
               <a:defRPr sz="1300">
                 <a:solidFill>
-                  <a:srgbClr val="CBD5E1"/>
+                  <a:srgbClr val="334155"/>
                 </a:solidFill>
                 <a:latin typeface="Segoe UI"/>
               </a:defRPr>
@@ -6148,7 +6148,7 @@
               </a:spcAft>
               <a:defRPr sz="1300">
                 <a:solidFill>
-                  <a:srgbClr val="CBD5E1"/>
+                  <a:srgbClr val="334155"/>
                 </a:solidFill>
                 <a:latin typeface="Segoe UI"/>
               </a:defRPr>
@@ -6164,7 +6164,7 @@
               </a:spcAft>
               <a:defRPr sz="1300">
                 <a:solidFill>
-                  <a:srgbClr val="CBD5E1"/>
+                  <a:srgbClr val="334155"/>
                 </a:solidFill>
                 <a:latin typeface="Segoe UI"/>
               </a:defRPr>
@@ -6180,7 +6180,7 @@
               </a:spcAft>
               <a:defRPr sz="1300">
                 <a:solidFill>
-                  <a:srgbClr val="CBD5E1"/>
+                  <a:srgbClr val="334155"/>
                 </a:solidFill>
                 <a:latin typeface="Segoe UI"/>
               </a:defRPr>
@@ -6196,7 +6196,7 @@
               </a:spcAft>
               <a:defRPr sz="1300">
                 <a:solidFill>
-                  <a:srgbClr val="CBD5E1"/>
+                  <a:srgbClr val="334155"/>
                 </a:solidFill>
                 <a:latin typeface="Segoe UI"/>
               </a:defRPr>
@@ -6222,11 +6222,11 @@
             <a:avLst/>
           </a:prstGeom>
           <a:solidFill>
-            <a:srgbClr val="131B2E"/>
+            <a:srgbClr val="F8FAFC"/>
           </a:solidFill>
-          <a:ln w="12700">
+          <a:ln w="15240">
             <a:solidFill>
-              <a:srgbClr val="283554"/>
+              <a:srgbClr val="E2E8F0"/>
             </a:solidFill>
           </a:ln>
         </p:spPr>
@@ -6277,7 +6277,7 @@
             <a:pPr>
               <a:defRPr sz="1500" b="1">
                 <a:solidFill>
-                  <a:srgbClr val="06B6D4"/>
+                  <a:srgbClr val="0369A1"/>
                 </a:solidFill>
                 <a:latin typeface="Segoe UI"/>
               </a:defRPr>
@@ -6316,7 +6316,7 @@
               </a:spcAft>
               <a:defRPr sz="1300">
                 <a:solidFill>
-                  <a:srgbClr val="CBD5E1"/>
+                  <a:srgbClr val="334155"/>
                 </a:solidFill>
                 <a:latin typeface="Segoe UI"/>
               </a:defRPr>
@@ -6332,7 +6332,7 @@
               </a:spcAft>
               <a:defRPr sz="1300">
                 <a:solidFill>
-                  <a:srgbClr val="CBD5E1"/>
+                  <a:srgbClr val="334155"/>
                 </a:solidFill>
                 <a:latin typeface="Segoe UI"/>
               </a:defRPr>
@@ -6348,7 +6348,7 @@
               </a:spcAft>
               <a:defRPr sz="1300">
                 <a:solidFill>
-                  <a:srgbClr val="CBD5E1"/>
+                  <a:srgbClr val="334155"/>
                 </a:solidFill>
                 <a:latin typeface="Segoe UI"/>
               </a:defRPr>
@@ -6364,7 +6364,7 @@
               </a:spcAft>
               <a:defRPr sz="1300">
                 <a:solidFill>
-                  <a:srgbClr val="CBD5E1"/>
+                  <a:srgbClr val="334155"/>
                 </a:solidFill>
                 <a:latin typeface="Segoe UI"/>
               </a:defRPr>
@@ -6380,7 +6380,7 @@
               </a:spcAft>
               <a:defRPr sz="1300">
                 <a:solidFill>
-                  <a:srgbClr val="CBD5E1"/>
+                  <a:srgbClr val="334155"/>
                 </a:solidFill>
                 <a:latin typeface="Segoe UI"/>
               </a:defRPr>
@@ -6424,7 +6424,7 @@
             <a:avLst/>
           </a:prstGeom>
           <a:solidFill>
-            <a:srgbClr val="0B0F19"/>
+            <a:srgbClr val="FFFFFF"/>
           </a:solidFill>
           <a:ln>
             <a:noFill/>
@@ -6467,7 +6467,7 @@
             <a:avLst/>
           </a:prstGeom>
           <a:solidFill>
-            <a:srgbClr val="6366F1"/>
+            <a:srgbClr val="4338CA"/>
           </a:solidFill>
           <a:ln>
             <a:noFill/>
@@ -6523,7 +6523,7 @@
               </a:spcAft>
               <a:defRPr sz="1100" b="1">
                 <a:solidFill>
-                  <a:srgbClr val="06B6D4"/>
+                  <a:srgbClr val="4338CA"/>
                 </a:solidFill>
                 <a:latin typeface="Segoe UI"/>
               </a:defRPr>
@@ -6539,7 +6539,7 @@
               </a:spcAft>
               <a:defRPr sz="2200" b="1">
                 <a:solidFill>
-                  <a:srgbClr val="FFFFFF"/>
+                  <a:srgbClr val="0F172A"/>
                 </a:solidFill>
                 <a:latin typeface="Segoe UI"/>
               </a:defRPr>
@@ -6552,7 +6552,7 @@
             <a:pPr>
               <a:defRPr sz="1300">
                 <a:solidFill>
-                  <a:srgbClr val="94A3B8"/>
+                  <a:srgbClr val="64748B"/>
                 </a:solidFill>
                 <a:latin typeface="Segoe UI"/>
               </a:defRPr>
@@ -6578,11 +6578,11 @@
             <a:avLst/>
           </a:prstGeom>
           <a:solidFill>
-            <a:srgbClr val="131B2E"/>
+            <a:srgbClr val="F8FAFC"/>
           </a:solidFill>
-          <a:ln w="12700">
+          <a:ln w="15240">
             <a:solidFill>
-              <a:srgbClr val="283554"/>
+              <a:srgbClr val="E2E8F0"/>
             </a:solidFill>
           </a:ln>
         </p:spPr>
@@ -6633,7 +6633,7 @@
             <a:pPr>
               <a:defRPr sz="2800" b="1">
                 <a:solidFill>
-                  <a:srgbClr val="06B6D4"/>
+                  <a:srgbClr val="0369A1"/>
                 </a:solidFill>
                 <a:latin typeface="Segoe UI"/>
               </a:defRPr>
@@ -6646,7 +6646,7 @@
             <a:pPr>
               <a:defRPr sz="1200">
                 <a:solidFill>
-                  <a:srgbClr val="94A3B8"/>
+                  <a:srgbClr val="64748B"/>
                 </a:solidFill>
                 <a:latin typeface="Segoe UI"/>
               </a:defRPr>
@@ -6672,11 +6672,11 @@
             <a:avLst/>
           </a:prstGeom>
           <a:solidFill>
-            <a:srgbClr val="131B2E"/>
+            <a:srgbClr val="F8FAFC"/>
           </a:solidFill>
-          <a:ln w="12700">
+          <a:ln w="15240">
             <a:solidFill>
-              <a:srgbClr val="283554"/>
+              <a:srgbClr val="E2E8F0"/>
             </a:solidFill>
           </a:ln>
         </p:spPr>
@@ -6727,7 +6727,7 @@
             <a:pPr>
               <a:defRPr sz="2800" b="1">
                 <a:solidFill>
-                  <a:srgbClr val="6366F1"/>
+                  <a:srgbClr val="4338CA"/>
                 </a:solidFill>
                 <a:latin typeface="Segoe UI"/>
               </a:defRPr>
@@ -6740,7 +6740,7 @@
             <a:pPr>
               <a:defRPr sz="1200">
                 <a:solidFill>
-                  <a:srgbClr val="94A3B8"/>
+                  <a:srgbClr val="64748B"/>
                 </a:solidFill>
                 <a:latin typeface="Segoe UI"/>
               </a:defRPr>
@@ -6766,11 +6766,11 @@
             <a:avLst/>
           </a:prstGeom>
           <a:solidFill>
-            <a:srgbClr val="131B2E"/>
+            <a:srgbClr val="F8FAFC"/>
           </a:solidFill>
-          <a:ln w="12700">
+          <a:ln w="15240">
             <a:solidFill>
-              <a:srgbClr val="283554"/>
+              <a:srgbClr val="E2E8F0"/>
             </a:solidFill>
           </a:ln>
         </p:spPr>
@@ -6821,7 +6821,7 @@
             <a:pPr>
               <a:defRPr sz="2800" b="1">
                 <a:solidFill>
-                  <a:srgbClr val="10B981"/>
+                  <a:srgbClr val="047857"/>
                 </a:solidFill>
                 <a:latin typeface="Segoe UI"/>
               </a:defRPr>
@@ -6834,7 +6834,7 @@
             <a:pPr>
               <a:defRPr sz="1200">
                 <a:solidFill>
-                  <a:srgbClr val="94A3B8"/>
+                  <a:srgbClr val="64748B"/>
                 </a:solidFill>
                 <a:latin typeface="Segoe UI"/>
               </a:defRPr>
@@ -6860,11 +6860,11 @@
             <a:avLst/>
           </a:prstGeom>
           <a:solidFill>
-            <a:srgbClr val="131B2E"/>
+            <a:srgbClr val="F8FAFC"/>
           </a:solidFill>
-          <a:ln w="12700">
+          <a:ln w="15240">
             <a:solidFill>
-              <a:srgbClr val="283554"/>
+              <a:srgbClr val="E2E8F0"/>
             </a:solidFill>
           </a:ln>
         </p:spPr>
@@ -6915,7 +6915,7 @@
             <a:pPr>
               <a:defRPr sz="2600" b="1">
                 <a:solidFill>
-                  <a:srgbClr val="F59E0B"/>
+                  <a:srgbClr val="B45309"/>
                 </a:solidFill>
                 <a:latin typeface="Segoe UI"/>
               </a:defRPr>
@@ -6928,7 +6928,7 @@
             <a:pPr>
               <a:defRPr sz="1200">
                 <a:solidFill>
-                  <a:srgbClr val="94A3B8"/>
+                  <a:srgbClr val="64748B"/>
                 </a:solidFill>
                 <a:latin typeface="Segoe UI"/>
               </a:defRPr>
@@ -6954,11 +6954,11 @@
             <a:avLst/>
           </a:prstGeom>
           <a:solidFill>
-            <a:srgbClr val="131B2E"/>
+            <a:srgbClr val="F8FAFC"/>
           </a:solidFill>
-          <a:ln w="12700">
+          <a:ln w="15240">
             <a:solidFill>
-              <a:srgbClr val="283554"/>
+              <a:srgbClr val="E2E8F0"/>
             </a:solidFill>
           </a:ln>
         </p:spPr>
@@ -7009,7 +7009,7 @@
             <a:pPr>
               <a:defRPr sz="1500" b="1">
                 <a:solidFill>
-                  <a:srgbClr val="FFFFFF"/>
+                  <a:srgbClr val="0F172A"/>
                 </a:solidFill>
                 <a:latin typeface="Segoe UI"/>
               </a:defRPr>
@@ -7048,7 +7048,7 @@
               </a:spcAft>
               <a:defRPr sz="1300">
                 <a:solidFill>
-                  <a:srgbClr val="CBD5E1"/>
+                  <a:srgbClr val="334155"/>
                 </a:solidFill>
                 <a:latin typeface="Segoe UI"/>
               </a:defRPr>
@@ -7064,7 +7064,7 @@
               </a:spcAft>
               <a:defRPr sz="1300">
                 <a:solidFill>
-                  <a:srgbClr val="CBD5E1"/>
+                  <a:srgbClr val="334155"/>
                 </a:solidFill>
                 <a:latin typeface="Segoe UI"/>
               </a:defRPr>
@@ -7080,7 +7080,7 @@
               </a:spcAft>
               <a:defRPr sz="1300">
                 <a:solidFill>
-                  <a:srgbClr val="CBD5E1"/>
+                  <a:srgbClr val="334155"/>
                 </a:solidFill>
                 <a:latin typeface="Segoe UI"/>
               </a:defRPr>
@@ -7096,7 +7096,7 @@
               </a:spcAft>
               <a:defRPr sz="1300">
                 <a:solidFill>
-                  <a:srgbClr val="CBD5E1"/>
+                  <a:srgbClr val="334155"/>
                 </a:solidFill>
                 <a:latin typeface="Segoe UI"/>
               </a:defRPr>
@@ -7140,7 +7140,7 @@
             <a:avLst/>
           </a:prstGeom>
           <a:solidFill>
-            <a:srgbClr val="0B0F19"/>
+            <a:srgbClr val="FFFFFF"/>
           </a:solidFill>
           <a:ln>
             <a:noFill/>
@@ -7183,7 +7183,7 @@
             <a:avLst/>
           </a:prstGeom>
           <a:solidFill>
-            <a:srgbClr val="6366F1"/>
+            <a:srgbClr val="4338CA"/>
           </a:solidFill>
           <a:ln>
             <a:noFill/>
@@ -7239,7 +7239,7 @@
               </a:spcAft>
               <a:defRPr sz="1100" b="1">
                 <a:solidFill>
-                  <a:srgbClr val="06B6D4"/>
+                  <a:srgbClr val="4338CA"/>
                 </a:solidFill>
                 <a:latin typeface="Segoe UI"/>
               </a:defRPr>
@@ -7255,7 +7255,7 @@
               </a:spcAft>
               <a:defRPr sz="2200" b="1">
                 <a:solidFill>
-                  <a:srgbClr val="FFFFFF"/>
+                  <a:srgbClr val="0F172A"/>
                 </a:solidFill>
                 <a:latin typeface="Segoe UI"/>
               </a:defRPr>
@@ -7268,7 +7268,7 @@
             <a:pPr>
               <a:defRPr sz="1300">
                 <a:solidFill>
-                  <a:srgbClr val="94A3B8"/>
+                  <a:srgbClr val="64748B"/>
                 </a:solidFill>
                 <a:latin typeface="Segoe UI"/>
               </a:defRPr>
@@ -7294,11 +7294,11 @@
             <a:avLst/>
           </a:prstGeom>
           <a:solidFill>
-            <a:srgbClr val="131B2E"/>
+            <a:srgbClr val="F8FAFC"/>
           </a:solidFill>
-          <a:ln w="12700">
+          <a:ln w="15240">
             <a:solidFill>
-              <a:srgbClr val="283554"/>
+              <a:srgbClr val="E2E8F0"/>
             </a:solidFill>
           </a:ln>
         </p:spPr>
@@ -7349,7 +7349,7 @@
             <a:pPr>
               <a:defRPr sz="1500" b="1">
                 <a:solidFill>
-                  <a:srgbClr val="10B981"/>
+                  <a:srgbClr val="047857"/>
                 </a:solidFill>
                 <a:latin typeface="Segoe UI"/>
               </a:defRPr>
@@ -7388,7 +7388,7 @@
               </a:spcAft>
               <a:defRPr sz="1300">
                 <a:solidFill>
-                  <a:srgbClr val="CBD5E1"/>
+                  <a:srgbClr val="334155"/>
                 </a:solidFill>
                 <a:latin typeface="Segoe UI"/>
               </a:defRPr>
@@ -7404,7 +7404,7 @@
               </a:spcAft>
               <a:defRPr sz="1300">
                 <a:solidFill>
-                  <a:srgbClr val="CBD5E1"/>
+                  <a:srgbClr val="334155"/>
                 </a:solidFill>
                 <a:latin typeface="Segoe UI"/>
               </a:defRPr>
@@ -7420,7 +7420,7 @@
               </a:spcAft>
               <a:defRPr sz="1300">
                 <a:solidFill>
-                  <a:srgbClr val="CBD5E1"/>
+                  <a:srgbClr val="334155"/>
                 </a:solidFill>
                 <a:latin typeface="Segoe UI"/>
               </a:defRPr>
@@ -7436,7 +7436,7 @@
               </a:spcAft>
               <a:defRPr sz="1300">
                 <a:solidFill>
-                  <a:srgbClr val="CBD5E1"/>
+                  <a:srgbClr val="334155"/>
                 </a:solidFill>
                 <a:latin typeface="Segoe UI"/>
               </a:defRPr>
@@ -7452,7 +7452,7 @@
               </a:spcAft>
               <a:defRPr sz="1300">
                 <a:solidFill>
-                  <a:srgbClr val="CBD5E1"/>
+                  <a:srgbClr val="334155"/>
                 </a:solidFill>
                 <a:latin typeface="Segoe UI"/>
               </a:defRPr>
@@ -7478,11 +7478,11 @@
             <a:avLst/>
           </a:prstGeom>
           <a:solidFill>
-            <a:srgbClr val="131B2E"/>
+            <a:srgbClr val="F8FAFC"/>
           </a:solidFill>
-          <a:ln w="12700">
+          <a:ln w="15240">
             <a:solidFill>
-              <a:srgbClr val="283554"/>
+              <a:srgbClr val="E2E8F0"/>
             </a:solidFill>
           </a:ln>
         </p:spPr>
@@ -7533,7 +7533,7 @@
             <a:pPr>
               <a:defRPr sz="1500" b="1">
                 <a:solidFill>
-                  <a:srgbClr val="06B6D4"/>
+                  <a:srgbClr val="0369A1"/>
                 </a:solidFill>
                 <a:latin typeface="Segoe UI"/>
               </a:defRPr>
@@ -7572,7 +7572,7 @@
               </a:spcAft>
               <a:defRPr sz="1300">
                 <a:solidFill>
-                  <a:srgbClr val="CBD5E1"/>
+                  <a:srgbClr val="334155"/>
                 </a:solidFill>
                 <a:latin typeface="Segoe UI"/>
               </a:defRPr>
@@ -7588,7 +7588,7 @@
               </a:spcAft>
               <a:defRPr sz="1300">
                 <a:solidFill>
-                  <a:srgbClr val="CBD5E1"/>
+                  <a:srgbClr val="334155"/>
                 </a:solidFill>
                 <a:latin typeface="Segoe UI"/>
               </a:defRPr>
@@ -7604,7 +7604,7 @@
               </a:spcAft>
               <a:defRPr sz="1300">
                 <a:solidFill>
-                  <a:srgbClr val="CBD5E1"/>
+                  <a:srgbClr val="334155"/>
                 </a:solidFill>
                 <a:latin typeface="Segoe UI"/>
               </a:defRPr>
@@ -7620,7 +7620,7 @@
               </a:spcAft>
               <a:defRPr sz="1300">
                 <a:solidFill>
-                  <a:srgbClr val="CBD5E1"/>
+                  <a:srgbClr val="334155"/>
                 </a:solidFill>
                 <a:latin typeface="Segoe UI"/>
               </a:defRPr>
@@ -7636,7 +7636,7 @@
               </a:spcAft>
               <a:defRPr sz="1300">
                 <a:solidFill>
-                  <a:srgbClr val="CBD5E1"/>
+                  <a:srgbClr val="334155"/>
                 </a:solidFill>
                 <a:latin typeface="Segoe UI"/>
               </a:defRPr>
@@ -7680,7 +7680,7 @@
             <a:avLst/>
           </a:prstGeom>
           <a:solidFill>
-            <a:srgbClr val="0B0F19"/>
+            <a:srgbClr val="FFFFFF"/>
           </a:solidFill>
           <a:ln>
             <a:noFill/>
@@ -7723,7 +7723,7 @@
             <a:avLst/>
           </a:prstGeom>
           <a:solidFill>
-            <a:srgbClr val="6366F1"/>
+            <a:srgbClr val="4338CA"/>
           </a:solidFill>
           <a:ln>
             <a:noFill/>
@@ -7766,11 +7766,11 @@
             <a:avLst/>
           </a:prstGeom>
           <a:solidFill>
-            <a:srgbClr val="131B2E"/>
+            <a:srgbClr val="F8FAFC"/>
           </a:solidFill>
           <a:ln w="19050">
             <a:solidFill>
-              <a:srgbClr val="283554"/>
+              <a:srgbClr val="E2E8F0"/>
             </a:solidFill>
           </a:ln>
         </p:spPr>
@@ -7824,7 +7824,7 @@
               </a:spcAft>
               <a:defRPr sz="1300" b="1">
                 <a:solidFill>
-                  <a:srgbClr val="06B6D4"/>
+                  <a:srgbClr val="4338CA"/>
                 </a:solidFill>
                 <a:latin typeface="Segoe UI"/>
               </a:defRPr>
@@ -7840,7 +7840,7 @@
               </a:spcAft>
               <a:defRPr sz="2600" b="1">
                 <a:solidFill>
-                  <a:srgbClr val="FFFFFF"/>
+                  <a:srgbClr val="0F172A"/>
                 </a:solidFill>
                 <a:latin typeface="Segoe UI"/>
               </a:defRPr>
@@ -7856,7 +7856,7 @@
               </a:spcAft>
               <a:defRPr sz="1400">
                 <a:solidFill>
-                  <a:srgbClr val="10B981"/>
+                  <a:srgbClr val="4338CA"/>
                 </a:solidFill>
                 <a:latin typeface="Segoe UI"/>
               </a:defRPr>
@@ -7873,7 +7873,7 @@
             <a:pPr algn="ctr">
               <a:defRPr sz="1400" b="1">
                 <a:solidFill>
-                  <a:srgbClr val="CBD5E1"/>
+                  <a:srgbClr val="334155"/>
                 </a:solidFill>
                 <a:latin typeface="Segoe UI"/>
               </a:defRPr>
@@ -7917,7 +7917,7 @@
             <a:avLst/>
           </a:prstGeom>
           <a:solidFill>
-            <a:srgbClr val="0B0F19"/>
+            <a:srgbClr val="FFFFFF"/>
           </a:solidFill>
           <a:ln>
             <a:noFill/>
@@ -7960,7 +7960,7 @@
             <a:avLst/>
           </a:prstGeom>
           <a:solidFill>
-            <a:srgbClr val="6366F1"/>
+            <a:srgbClr val="4338CA"/>
           </a:solidFill>
           <a:ln>
             <a:noFill/>
@@ -8016,7 +8016,7 @@
               </a:spcAft>
               <a:defRPr sz="1100" b="1">
                 <a:solidFill>
-                  <a:srgbClr val="06B6D4"/>
+                  <a:srgbClr val="4338CA"/>
                 </a:solidFill>
                 <a:latin typeface="Segoe UI"/>
               </a:defRPr>
@@ -8032,7 +8032,7 @@
               </a:spcAft>
               <a:defRPr sz="2200" b="1">
                 <a:solidFill>
-                  <a:srgbClr val="FFFFFF"/>
+                  <a:srgbClr val="0F172A"/>
                 </a:solidFill>
                 <a:latin typeface="Segoe UI"/>
               </a:defRPr>
@@ -8045,7 +8045,7 @@
             <a:pPr>
               <a:defRPr sz="1300">
                 <a:solidFill>
-                  <a:srgbClr val="94A3B8"/>
+                  <a:srgbClr val="64748B"/>
                 </a:solidFill>
                 <a:latin typeface="Segoe UI"/>
               </a:defRPr>
@@ -8071,11 +8071,11 @@
             <a:avLst/>
           </a:prstGeom>
           <a:solidFill>
-            <a:srgbClr val="131B2E"/>
+            <a:srgbClr val="F8FAFC"/>
           </a:solidFill>
-          <a:ln w="12700">
+          <a:ln w="15240">
             <a:solidFill>
-              <a:srgbClr val="283554"/>
+              <a:srgbClr val="E2E8F0"/>
             </a:solidFill>
           </a:ln>
         </p:spPr>
@@ -8126,7 +8126,7 @@
             <a:pPr>
               <a:defRPr sz="1500" b="1">
                 <a:solidFill>
-                  <a:srgbClr val="F59E0B"/>
+                  <a:srgbClr val="B45309"/>
                 </a:solidFill>
                 <a:latin typeface="Segoe UI"/>
               </a:defRPr>
@@ -8165,7 +8165,7 @@
               </a:spcAft>
               <a:defRPr sz="1300">
                 <a:solidFill>
-                  <a:srgbClr val="CBD5E1"/>
+                  <a:srgbClr val="334155"/>
                 </a:solidFill>
                 <a:latin typeface="Segoe UI"/>
               </a:defRPr>
@@ -8181,7 +8181,7 @@
               </a:spcAft>
               <a:defRPr sz="1300">
                 <a:solidFill>
-                  <a:srgbClr val="CBD5E1"/>
+                  <a:srgbClr val="334155"/>
                 </a:solidFill>
                 <a:latin typeface="Segoe UI"/>
               </a:defRPr>
@@ -8197,7 +8197,7 @@
               </a:spcAft>
               <a:defRPr sz="1300">
                 <a:solidFill>
-                  <a:srgbClr val="CBD5E1"/>
+                  <a:srgbClr val="334155"/>
                 </a:solidFill>
                 <a:latin typeface="Segoe UI"/>
               </a:defRPr>
@@ -8213,7 +8213,7 @@
               </a:spcAft>
               <a:defRPr sz="1300">
                 <a:solidFill>
-                  <a:srgbClr val="CBD5E1"/>
+                  <a:srgbClr val="334155"/>
                 </a:solidFill>
                 <a:latin typeface="Segoe UI"/>
               </a:defRPr>
@@ -8229,7 +8229,7 @@
               </a:spcAft>
               <a:defRPr sz="1300">
                 <a:solidFill>
-                  <a:srgbClr val="CBD5E1"/>
+                  <a:srgbClr val="334155"/>
                 </a:solidFill>
                 <a:latin typeface="Segoe UI"/>
               </a:defRPr>
@@ -8255,11 +8255,11 @@
             <a:avLst/>
           </a:prstGeom>
           <a:solidFill>
-            <a:srgbClr val="131B2E"/>
+            <a:srgbClr val="F8FAFC"/>
           </a:solidFill>
-          <a:ln w="12700">
+          <a:ln w="15240">
             <a:solidFill>
-              <a:srgbClr val="283554"/>
+              <a:srgbClr val="E2E8F0"/>
             </a:solidFill>
           </a:ln>
         </p:spPr>
@@ -8310,7 +8310,7 @@
             <a:pPr>
               <a:defRPr sz="1500" b="1">
                 <a:solidFill>
-                  <a:srgbClr val="10B981"/>
+                  <a:srgbClr val="047857"/>
                 </a:solidFill>
                 <a:latin typeface="Segoe UI"/>
               </a:defRPr>
@@ -8349,7 +8349,7 @@
               </a:spcAft>
               <a:defRPr sz="1300">
                 <a:solidFill>
-                  <a:srgbClr val="CBD5E1"/>
+                  <a:srgbClr val="334155"/>
                 </a:solidFill>
                 <a:latin typeface="Segoe UI"/>
               </a:defRPr>
@@ -8365,7 +8365,7 @@
               </a:spcAft>
               <a:defRPr sz="1300">
                 <a:solidFill>
-                  <a:srgbClr val="CBD5E1"/>
+                  <a:srgbClr val="334155"/>
                 </a:solidFill>
                 <a:latin typeface="Segoe UI"/>
               </a:defRPr>
@@ -8381,7 +8381,7 @@
               </a:spcAft>
               <a:defRPr sz="1300">
                 <a:solidFill>
-                  <a:srgbClr val="CBD5E1"/>
+                  <a:srgbClr val="334155"/>
                 </a:solidFill>
                 <a:latin typeface="Segoe UI"/>
               </a:defRPr>
@@ -8397,7 +8397,7 @@
               </a:spcAft>
               <a:defRPr sz="1300">
                 <a:solidFill>
-                  <a:srgbClr val="CBD5E1"/>
+                  <a:srgbClr val="334155"/>
                 </a:solidFill>
                 <a:latin typeface="Segoe UI"/>
               </a:defRPr>
@@ -8413,7 +8413,7 @@
               </a:spcAft>
               <a:defRPr sz="1300">
                 <a:solidFill>
-                  <a:srgbClr val="CBD5E1"/>
+                  <a:srgbClr val="334155"/>
                 </a:solidFill>
                 <a:latin typeface="Segoe UI"/>
               </a:defRPr>
@@ -8457,7 +8457,7 @@
             <a:avLst/>
           </a:prstGeom>
           <a:solidFill>
-            <a:srgbClr val="0B0F19"/>
+            <a:srgbClr val="FFFFFF"/>
           </a:solidFill>
           <a:ln>
             <a:noFill/>
@@ -8500,7 +8500,7 @@
             <a:avLst/>
           </a:prstGeom>
           <a:solidFill>
-            <a:srgbClr val="6366F1"/>
+            <a:srgbClr val="4338CA"/>
           </a:solidFill>
           <a:ln>
             <a:noFill/>
@@ -8556,7 +8556,7 @@
               </a:spcAft>
               <a:defRPr sz="1100" b="1">
                 <a:solidFill>
-                  <a:srgbClr val="06B6D4"/>
+                  <a:srgbClr val="4338CA"/>
                 </a:solidFill>
                 <a:latin typeface="Segoe UI"/>
               </a:defRPr>
@@ -8572,20 +8572,20 @@
               </a:spcAft>
               <a:defRPr sz="2200" b="1">
                 <a:solidFill>
-                  <a:srgbClr val="FFFFFF"/>
-                </a:solidFill>
-                <a:latin typeface="Segoe UI"/>
-              </a:defRPr>
-            </a:pPr>
-            <a:r>
-              <a:t>Thành Viên &amp; Phân Công Công Việc</a:t>
-            </a:r>
-          </a:p>
-          <a:p>
-            <a:pPr>
-              <a:defRPr sz="1300">
-                <a:solidFill>
-                  <a:srgbClr val="94A3B8"/>
+                  <a:srgbClr val="0F172A"/>
+                </a:solidFill>
+                <a:latin typeface="Segoe UI"/>
+              </a:defRPr>
+            </a:pPr>
+            <a:r>
+              <a:t>Thành Viên &amp; PhÂN CÔNG CÔNG VIỆC</a:t>
+            </a:r>
+          </a:p>
+          <a:p>
+            <a:pPr>
+              <a:defRPr sz="1300">
+                <a:solidFill>
+                  <a:srgbClr val="64748B"/>
                 </a:solidFill>
                 <a:latin typeface="Segoe UI"/>
               </a:defRPr>
@@ -8611,11 +8611,11 @@
             <a:avLst/>
           </a:prstGeom>
           <a:solidFill>
-            <a:srgbClr val="131B2E"/>
+            <a:srgbClr val="F8FAFC"/>
           </a:solidFill>
-          <a:ln w="12700">
+          <a:ln w="15240">
             <a:solidFill>
-              <a:srgbClr val="283554"/>
+              <a:srgbClr val="E2E8F0"/>
             </a:solidFill>
           </a:ln>
         </p:spPr>
@@ -8666,7 +8666,7 @@
             <a:pPr>
               <a:defRPr sz="1500" b="1">
                 <a:solidFill>
-                  <a:srgbClr val="6366F1"/>
+                  <a:srgbClr val="4338CA"/>
                 </a:solidFill>
                 <a:latin typeface="Segoe UI"/>
               </a:defRPr>
@@ -8705,7 +8705,7 @@
               </a:spcAft>
               <a:defRPr sz="1300">
                 <a:solidFill>
-                  <a:srgbClr val="CBD5E1"/>
+                  <a:srgbClr val="334155"/>
                 </a:solidFill>
                 <a:latin typeface="Segoe UI"/>
               </a:defRPr>
@@ -8721,7 +8721,7 @@
               </a:spcAft>
               <a:defRPr sz="1300">
                 <a:solidFill>
-                  <a:srgbClr val="CBD5E1"/>
+                  <a:srgbClr val="334155"/>
                 </a:solidFill>
                 <a:latin typeface="Segoe UI"/>
               </a:defRPr>
@@ -8737,7 +8737,7 @@
               </a:spcAft>
               <a:defRPr sz="1300">
                 <a:solidFill>
-                  <a:srgbClr val="CBD5E1"/>
+                  <a:srgbClr val="334155"/>
                 </a:solidFill>
                 <a:latin typeface="Segoe UI"/>
               </a:defRPr>
@@ -8753,7 +8753,7 @@
               </a:spcAft>
               <a:defRPr sz="1300">
                 <a:solidFill>
-                  <a:srgbClr val="CBD5E1"/>
+                  <a:srgbClr val="334155"/>
                 </a:solidFill>
                 <a:latin typeface="Segoe UI"/>
               </a:defRPr>
@@ -8769,7 +8769,7 @@
               </a:spcAft>
               <a:defRPr sz="1300">
                 <a:solidFill>
-                  <a:srgbClr val="CBD5E1"/>
+                  <a:srgbClr val="334155"/>
                 </a:solidFill>
                 <a:latin typeface="Segoe UI"/>
               </a:defRPr>
@@ -8795,11 +8795,11 @@
             <a:avLst/>
           </a:prstGeom>
           <a:solidFill>
-            <a:srgbClr val="131B2E"/>
+            <a:srgbClr val="F8FAFC"/>
           </a:solidFill>
-          <a:ln w="12700">
+          <a:ln w="15240">
             <a:solidFill>
-              <a:srgbClr val="283554"/>
+              <a:srgbClr val="E2E8F0"/>
             </a:solidFill>
           </a:ln>
         </p:spPr>
@@ -8850,7 +8850,7 @@
             <a:pPr>
               <a:defRPr sz="1500" b="1">
                 <a:solidFill>
-                  <a:srgbClr val="06B6D4"/>
+                  <a:srgbClr val="0369A1"/>
                 </a:solidFill>
                 <a:latin typeface="Segoe UI"/>
               </a:defRPr>
@@ -8889,7 +8889,7 @@
               </a:spcAft>
               <a:defRPr sz="1300">
                 <a:solidFill>
-                  <a:srgbClr val="CBD5E1"/>
+                  <a:srgbClr val="334155"/>
                 </a:solidFill>
                 <a:latin typeface="Segoe UI"/>
               </a:defRPr>
@@ -8905,23 +8905,23 @@
               </a:spcAft>
               <a:defRPr sz="1300">
                 <a:solidFill>
-                  <a:srgbClr val="CBD5E1"/>
-                </a:solidFill>
-                <a:latin typeface="Segoe UI"/>
-              </a:defRPr>
-            </a:pPr>
-            <a:r>
-              <a:t>• Dark Mode hiện đại với TailwindCSS.</a:t>
-            </a:r>
-          </a:p>
-          <a:p>
-            <a:pPr>
-              <a:spcAft>
-                <a:spcPts val="700"/>
-              </a:spcAft>
-              <a:defRPr sz="1300">
-                <a:solidFill>
-                  <a:srgbClr val="CBD5E1"/>
+                  <a:srgbClr val="334155"/>
+                </a:solidFill>
+                <a:latin typeface="Segoe UI"/>
+              </a:defRPr>
+            </a:pPr>
+            <a:r>
+              <a:t>• Thiết kế giao diện hiện đại &amp; responsive.</a:t>
+            </a:r>
+          </a:p>
+          <a:p>
+            <a:pPr>
+              <a:spcAft>
+                <a:spcPts val="700"/>
+              </a:spcAft>
+              <a:defRPr sz="1300">
+                <a:solidFill>
+                  <a:srgbClr val="334155"/>
                 </a:solidFill>
                 <a:latin typeface="Segoe UI"/>
               </a:defRPr>
@@ -8937,7 +8937,7 @@
               </a:spcAft>
               <a:defRPr sz="1300">
                 <a:solidFill>
-                  <a:srgbClr val="CBD5E1"/>
+                  <a:srgbClr val="334155"/>
                 </a:solidFill>
                 <a:latin typeface="Segoe UI"/>
               </a:defRPr>
@@ -8953,7 +8953,7 @@
               </a:spcAft>
               <a:defRPr sz="1300">
                 <a:solidFill>
-                  <a:srgbClr val="CBD5E1"/>
+                  <a:srgbClr val="334155"/>
                 </a:solidFill>
                 <a:latin typeface="Segoe UI"/>
               </a:defRPr>
@@ -8979,11 +8979,11 @@
             <a:avLst/>
           </a:prstGeom>
           <a:solidFill>
-            <a:srgbClr val="131B2E"/>
+            <a:srgbClr val="F8FAFC"/>
           </a:solidFill>
-          <a:ln w="12700">
+          <a:ln w="15240">
             <a:solidFill>
-              <a:srgbClr val="283554"/>
+              <a:srgbClr val="E2E8F0"/>
             </a:solidFill>
           </a:ln>
         </p:spPr>
@@ -9034,7 +9034,7 @@
             <a:pPr>
               <a:defRPr sz="1500" b="1">
                 <a:solidFill>
-                  <a:srgbClr val="10B981"/>
+                  <a:srgbClr val="047857"/>
                 </a:solidFill>
                 <a:latin typeface="Segoe UI"/>
               </a:defRPr>
@@ -9073,7 +9073,7 @@
               </a:spcAft>
               <a:defRPr sz="1300">
                 <a:solidFill>
-                  <a:srgbClr val="CBD5E1"/>
+                  <a:srgbClr val="334155"/>
                 </a:solidFill>
                 <a:latin typeface="Segoe UI"/>
               </a:defRPr>
@@ -9089,7 +9089,7 @@
               </a:spcAft>
               <a:defRPr sz="1300">
                 <a:solidFill>
-                  <a:srgbClr val="CBD5E1"/>
+                  <a:srgbClr val="334155"/>
                 </a:solidFill>
                 <a:latin typeface="Segoe UI"/>
               </a:defRPr>
@@ -9105,7 +9105,7 @@
               </a:spcAft>
               <a:defRPr sz="1300">
                 <a:solidFill>
-                  <a:srgbClr val="CBD5E1"/>
+                  <a:srgbClr val="334155"/>
                 </a:solidFill>
                 <a:latin typeface="Segoe UI"/>
               </a:defRPr>
@@ -9121,7 +9121,7 @@
               </a:spcAft>
               <a:defRPr sz="1300">
                 <a:solidFill>
-                  <a:srgbClr val="CBD5E1"/>
+                  <a:srgbClr val="334155"/>
                 </a:solidFill>
                 <a:latin typeface="Segoe UI"/>
               </a:defRPr>
@@ -9137,7 +9137,7 @@
               </a:spcAft>
               <a:defRPr sz="1300">
                 <a:solidFill>
-                  <a:srgbClr val="CBD5E1"/>
+                  <a:srgbClr val="334155"/>
                 </a:solidFill>
                 <a:latin typeface="Segoe UI"/>
               </a:defRPr>
@@ -9181,7 +9181,7 @@
             <a:avLst/>
           </a:prstGeom>
           <a:solidFill>
-            <a:srgbClr val="0B0F19"/>
+            <a:srgbClr val="FFFFFF"/>
           </a:solidFill>
           <a:ln>
             <a:noFill/>
@@ -9224,7 +9224,7 @@
             <a:avLst/>
           </a:prstGeom>
           <a:solidFill>
-            <a:srgbClr val="6366F1"/>
+            <a:srgbClr val="4338CA"/>
           </a:solidFill>
           <a:ln>
             <a:noFill/>
@@ -9280,7 +9280,7 @@
               </a:spcAft>
               <a:defRPr sz="1100" b="1">
                 <a:solidFill>
-                  <a:srgbClr val="06B6D4"/>
+                  <a:srgbClr val="4338CA"/>
                 </a:solidFill>
                 <a:latin typeface="Segoe UI"/>
               </a:defRPr>
@@ -9296,7 +9296,7 @@
               </a:spcAft>
               <a:defRPr sz="2200" b="1">
                 <a:solidFill>
-                  <a:srgbClr val="FFFFFF"/>
+                  <a:srgbClr val="0F172A"/>
                 </a:solidFill>
                 <a:latin typeface="Segoe UI"/>
               </a:defRPr>
@@ -9309,7 +9309,7 @@
             <a:pPr>
               <a:defRPr sz="1300">
                 <a:solidFill>
-                  <a:srgbClr val="94A3B8"/>
+                  <a:srgbClr val="64748B"/>
                 </a:solidFill>
                 <a:latin typeface="Segoe UI"/>
               </a:defRPr>
@@ -9335,11 +9335,11 @@
             <a:avLst/>
           </a:prstGeom>
           <a:solidFill>
-            <a:srgbClr val="131B2E"/>
+            <a:srgbClr val="F8FAFC"/>
           </a:solidFill>
-          <a:ln w="12700">
+          <a:ln w="15240">
             <a:solidFill>
-              <a:srgbClr val="283554"/>
+              <a:srgbClr val="E2E8F0"/>
             </a:solidFill>
           </a:ln>
         </p:spPr>
@@ -9390,7 +9390,7 @@
             <a:pPr>
               <a:defRPr sz="1500" b="1">
                 <a:solidFill>
-                  <a:srgbClr val="6366F1"/>
+                  <a:srgbClr val="4338CA"/>
                 </a:solidFill>
                 <a:latin typeface="Segoe UI"/>
               </a:defRPr>
@@ -9429,7 +9429,7 @@
               </a:spcAft>
               <a:defRPr sz="1300">
                 <a:solidFill>
-                  <a:srgbClr val="CBD5E1"/>
+                  <a:srgbClr val="334155"/>
                 </a:solidFill>
                 <a:latin typeface="Segoe UI"/>
               </a:defRPr>
@@ -9445,7 +9445,7 @@
               </a:spcAft>
               <a:defRPr sz="1300">
                 <a:solidFill>
-                  <a:srgbClr val="CBD5E1"/>
+                  <a:srgbClr val="334155"/>
                 </a:solidFill>
                 <a:latin typeface="Segoe UI"/>
               </a:defRPr>
@@ -9461,7 +9461,7 @@
               </a:spcAft>
               <a:defRPr sz="1300">
                 <a:solidFill>
-                  <a:srgbClr val="CBD5E1"/>
+                  <a:srgbClr val="334155"/>
                 </a:solidFill>
                 <a:latin typeface="Segoe UI"/>
               </a:defRPr>
@@ -9477,7 +9477,7 @@
               </a:spcAft>
               <a:defRPr sz="1300">
                 <a:solidFill>
-                  <a:srgbClr val="CBD5E1"/>
+                  <a:srgbClr val="334155"/>
                 </a:solidFill>
                 <a:latin typeface="Segoe UI"/>
               </a:defRPr>
@@ -9503,11 +9503,11 @@
             <a:avLst/>
           </a:prstGeom>
           <a:solidFill>
-            <a:srgbClr val="131B2E"/>
+            <a:srgbClr val="F8FAFC"/>
           </a:solidFill>
-          <a:ln w="12700">
+          <a:ln w="15240">
             <a:solidFill>
-              <a:srgbClr val="283554"/>
+              <a:srgbClr val="E2E8F0"/>
             </a:solidFill>
           </a:ln>
         </p:spPr>
@@ -9558,7 +9558,7 @@
             <a:pPr>
               <a:defRPr sz="1500" b="1">
                 <a:solidFill>
-                  <a:srgbClr val="06B6D4"/>
+                  <a:srgbClr val="0369A1"/>
                 </a:solidFill>
                 <a:latin typeface="Segoe UI"/>
               </a:defRPr>
@@ -9597,7 +9597,7 @@
               </a:spcAft>
               <a:defRPr sz="1300">
                 <a:solidFill>
-                  <a:srgbClr val="CBD5E1"/>
+                  <a:srgbClr val="334155"/>
                 </a:solidFill>
                 <a:latin typeface="Segoe UI"/>
               </a:defRPr>
@@ -9613,7 +9613,7 @@
               </a:spcAft>
               <a:defRPr sz="1300">
                 <a:solidFill>
-                  <a:srgbClr val="CBD5E1"/>
+                  <a:srgbClr val="334155"/>
                 </a:solidFill>
                 <a:latin typeface="Segoe UI"/>
               </a:defRPr>
@@ -9629,7 +9629,7 @@
               </a:spcAft>
               <a:defRPr sz="1300">
                 <a:solidFill>
-                  <a:srgbClr val="CBD5E1"/>
+                  <a:srgbClr val="334155"/>
                 </a:solidFill>
                 <a:latin typeface="Segoe UI"/>
               </a:defRPr>
@@ -9645,7 +9645,7 @@
               </a:spcAft>
               <a:defRPr sz="1300">
                 <a:solidFill>
-                  <a:srgbClr val="CBD5E1"/>
+                  <a:srgbClr val="334155"/>
                 </a:solidFill>
                 <a:latin typeface="Segoe UI"/>
               </a:defRPr>
@@ -9671,11 +9671,11 @@
             <a:avLst/>
           </a:prstGeom>
           <a:solidFill>
-            <a:srgbClr val="131B2E"/>
+            <a:srgbClr val="F8FAFC"/>
           </a:solidFill>
-          <a:ln w="12700">
+          <a:ln w="15240">
             <a:solidFill>
-              <a:srgbClr val="283554"/>
+              <a:srgbClr val="E2E8F0"/>
             </a:solidFill>
           </a:ln>
         </p:spPr>
@@ -9726,7 +9726,7 @@
             <a:pPr>
               <a:defRPr sz="1500" b="1">
                 <a:solidFill>
-                  <a:srgbClr val="F59E0B"/>
+                  <a:srgbClr val="B45309"/>
                 </a:solidFill>
                 <a:latin typeface="Segoe UI"/>
               </a:defRPr>
@@ -9765,7 +9765,7 @@
               </a:spcAft>
               <a:defRPr sz="1300">
                 <a:solidFill>
-                  <a:srgbClr val="CBD5E1"/>
+                  <a:srgbClr val="334155"/>
                 </a:solidFill>
                 <a:latin typeface="Segoe UI"/>
               </a:defRPr>
@@ -9781,7 +9781,7 @@
               </a:spcAft>
               <a:defRPr sz="1300">
                 <a:solidFill>
-                  <a:srgbClr val="CBD5E1"/>
+                  <a:srgbClr val="334155"/>
                 </a:solidFill>
                 <a:latin typeface="Segoe UI"/>
               </a:defRPr>
@@ -9797,7 +9797,7 @@
               </a:spcAft>
               <a:defRPr sz="1300">
                 <a:solidFill>
-                  <a:srgbClr val="CBD5E1"/>
+                  <a:srgbClr val="334155"/>
                 </a:solidFill>
                 <a:latin typeface="Segoe UI"/>
               </a:defRPr>
@@ -9813,7 +9813,7 @@
               </a:spcAft>
               <a:defRPr sz="1300">
                 <a:solidFill>
-                  <a:srgbClr val="CBD5E1"/>
+                  <a:srgbClr val="334155"/>
                 </a:solidFill>
                 <a:latin typeface="Segoe UI"/>
               </a:defRPr>
@@ -9839,11 +9839,11 @@
             <a:avLst/>
           </a:prstGeom>
           <a:solidFill>
-            <a:srgbClr val="131B2E"/>
+            <a:srgbClr val="F8FAFC"/>
           </a:solidFill>
-          <a:ln w="12700">
+          <a:ln w="15240">
             <a:solidFill>
-              <a:srgbClr val="283554"/>
+              <a:srgbClr val="E2E8F0"/>
             </a:solidFill>
           </a:ln>
         </p:spPr>
@@ -9894,7 +9894,7 @@
             <a:pPr>
               <a:defRPr sz="1500" b="1">
                 <a:solidFill>
-                  <a:srgbClr val="10B981"/>
+                  <a:srgbClr val="047857"/>
                 </a:solidFill>
                 <a:latin typeface="Segoe UI"/>
               </a:defRPr>
@@ -9933,7 +9933,7 @@
               </a:spcAft>
               <a:defRPr sz="1300">
                 <a:solidFill>
-                  <a:srgbClr val="CBD5E1"/>
+                  <a:srgbClr val="334155"/>
                 </a:solidFill>
                 <a:latin typeface="Segoe UI"/>
               </a:defRPr>
@@ -9949,7 +9949,7 @@
               </a:spcAft>
               <a:defRPr sz="1300">
                 <a:solidFill>
-                  <a:srgbClr val="CBD5E1"/>
+                  <a:srgbClr val="334155"/>
                 </a:solidFill>
                 <a:latin typeface="Segoe UI"/>
               </a:defRPr>
@@ -9965,7 +9965,7 @@
               </a:spcAft>
               <a:defRPr sz="1300">
                 <a:solidFill>
-                  <a:srgbClr val="CBD5E1"/>
+                  <a:srgbClr val="334155"/>
                 </a:solidFill>
                 <a:latin typeface="Segoe UI"/>
               </a:defRPr>
@@ -9981,7 +9981,7 @@
               </a:spcAft>
               <a:defRPr sz="1300">
                 <a:solidFill>
-                  <a:srgbClr val="CBD5E1"/>
+                  <a:srgbClr val="334155"/>
                 </a:solidFill>
                 <a:latin typeface="Segoe UI"/>
               </a:defRPr>
@@ -10025,7 +10025,7 @@
             <a:avLst/>
           </a:prstGeom>
           <a:solidFill>
-            <a:srgbClr val="0B0F19"/>
+            <a:srgbClr val="FFFFFF"/>
           </a:solidFill>
           <a:ln>
             <a:noFill/>
@@ -10068,7 +10068,7 @@
             <a:avLst/>
           </a:prstGeom>
           <a:solidFill>
-            <a:srgbClr val="6366F1"/>
+            <a:srgbClr val="4338CA"/>
           </a:solidFill>
           <a:ln>
             <a:noFill/>
@@ -10124,7 +10124,7 @@
               </a:spcAft>
               <a:defRPr sz="1100" b="1">
                 <a:solidFill>
-                  <a:srgbClr val="06B6D4"/>
+                  <a:srgbClr val="4338CA"/>
                 </a:solidFill>
                 <a:latin typeface="Segoe UI"/>
               </a:defRPr>
@@ -10140,7 +10140,7 @@
               </a:spcAft>
               <a:defRPr sz="2200" b="1">
                 <a:solidFill>
-                  <a:srgbClr val="FFFFFF"/>
+                  <a:srgbClr val="0F172A"/>
                 </a:solidFill>
                 <a:latin typeface="Segoe UI"/>
               </a:defRPr>
@@ -10153,7 +10153,7 @@
             <a:pPr>
               <a:defRPr sz="1300">
                 <a:solidFill>
-                  <a:srgbClr val="94A3B8"/>
+                  <a:srgbClr val="64748B"/>
                 </a:solidFill>
                 <a:latin typeface="Segoe UI"/>
               </a:defRPr>
@@ -10179,11 +10179,11 @@
             <a:avLst/>
           </a:prstGeom>
           <a:solidFill>
-            <a:srgbClr val="131B2E"/>
+            <a:srgbClr val="F8FAFC"/>
           </a:solidFill>
-          <a:ln w="12700">
+          <a:ln w="15240">
             <a:solidFill>
-              <a:srgbClr val="283554"/>
+              <a:srgbClr val="E2E8F0"/>
             </a:solidFill>
           </a:ln>
         </p:spPr>
@@ -10234,7 +10234,7 @@
             <a:pPr>
               <a:defRPr sz="1500" b="1">
                 <a:solidFill>
-                  <a:srgbClr val="06B6D4"/>
+                  <a:srgbClr val="0369A1"/>
                 </a:solidFill>
                 <a:latin typeface="Segoe UI"/>
               </a:defRPr>
@@ -10273,7 +10273,7 @@
               </a:spcAft>
               <a:defRPr sz="1300">
                 <a:solidFill>
-                  <a:srgbClr val="CBD5E1"/>
+                  <a:srgbClr val="334155"/>
                 </a:solidFill>
                 <a:latin typeface="Segoe UI"/>
               </a:defRPr>
@@ -10289,7 +10289,7 @@
               </a:spcAft>
               <a:defRPr sz="1300">
                 <a:solidFill>
-                  <a:srgbClr val="CBD5E1"/>
+                  <a:srgbClr val="334155"/>
                 </a:solidFill>
                 <a:latin typeface="Segoe UI"/>
               </a:defRPr>
@@ -10305,7 +10305,7 @@
               </a:spcAft>
               <a:defRPr sz="1300">
                 <a:solidFill>
-                  <a:srgbClr val="CBD5E1"/>
+                  <a:srgbClr val="334155"/>
                 </a:solidFill>
                 <a:latin typeface="Segoe UI"/>
               </a:defRPr>
@@ -10321,7 +10321,7 @@
               </a:spcAft>
               <a:defRPr sz="1300">
                 <a:solidFill>
-                  <a:srgbClr val="CBD5E1"/>
+                  <a:srgbClr val="334155"/>
                 </a:solidFill>
                 <a:latin typeface="Segoe UI"/>
               </a:defRPr>
@@ -10337,7 +10337,7 @@
               </a:spcAft>
               <a:defRPr sz="1300">
                 <a:solidFill>
-                  <a:srgbClr val="CBD5E1"/>
+                  <a:srgbClr val="334155"/>
                 </a:solidFill>
                 <a:latin typeface="Segoe UI"/>
               </a:defRPr>
@@ -10363,11 +10363,11 @@
             <a:avLst/>
           </a:prstGeom>
           <a:solidFill>
-            <a:srgbClr val="131B2E"/>
+            <a:srgbClr val="F8FAFC"/>
           </a:solidFill>
-          <a:ln w="12700">
+          <a:ln w="15240">
             <a:solidFill>
-              <a:srgbClr val="283554"/>
+              <a:srgbClr val="E2E8F0"/>
             </a:solidFill>
           </a:ln>
         </p:spPr>
@@ -10418,7 +10418,7 @@
             <a:pPr>
               <a:defRPr sz="1500" b="1">
                 <a:solidFill>
-                  <a:srgbClr val="6366F1"/>
+                  <a:srgbClr val="4338CA"/>
                 </a:solidFill>
                 <a:latin typeface="Segoe UI"/>
               </a:defRPr>
@@ -10457,7 +10457,7 @@
               </a:spcAft>
               <a:defRPr sz="1300">
                 <a:solidFill>
-                  <a:srgbClr val="CBD5E1"/>
+                  <a:srgbClr val="334155"/>
                 </a:solidFill>
                 <a:latin typeface="Segoe UI"/>
               </a:defRPr>
@@ -10473,7 +10473,7 @@
               </a:spcAft>
               <a:defRPr sz="1300">
                 <a:solidFill>
-                  <a:srgbClr val="CBD5E1"/>
+                  <a:srgbClr val="334155"/>
                 </a:solidFill>
                 <a:latin typeface="Segoe UI"/>
               </a:defRPr>
@@ -10489,7 +10489,7 @@
               </a:spcAft>
               <a:defRPr sz="1300">
                 <a:solidFill>
-                  <a:srgbClr val="CBD5E1"/>
+                  <a:srgbClr val="334155"/>
                 </a:solidFill>
                 <a:latin typeface="Segoe UI"/>
               </a:defRPr>
@@ -10505,7 +10505,7 @@
               </a:spcAft>
               <a:defRPr sz="1300">
                 <a:solidFill>
-                  <a:srgbClr val="CBD5E1"/>
+                  <a:srgbClr val="334155"/>
                 </a:solidFill>
                 <a:latin typeface="Segoe UI"/>
               </a:defRPr>
@@ -10521,7 +10521,7 @@
               </a:spcAft>
               <a:defRPr sz="1300">
                 <a:solidFill>
-                  <a:srgbClr val="CBD5E1"/>
+                  <a:srgbClr val="334155"/>
                 </a:solidFill>
                 <a:latin typeface="Segoe UI"/>
               </a:defRPr>
@@ -10565,7 +10565,7 @@
             <a:avLst/>
           </a:prstGeom>
           <a:solidFill>
-            <a:srgbClr val="0B0F19"/>
+            <a:srgbClr val="FFFFFF"/>
           </a:solidFill>
           <a:ln>
             <a:noFill/>
@@ -10608,7 +10608,7 @@
             <a:avLst/>
           </a:prstGeom>
           <a:solidFill>
-            <a:srgbClr val="6366F1"/>
+            <a:srgbClr val="4338CA"/>
           </a:solidFill>
           <a:ln>
             <a:noFill/>
@@ -10664,7 +10664,7 @@
               </a:spcAft>
               <a:defRPr sz="1100" b="1">
                 <a:solidFill>
-                  <a:srgbClr val="06B6D4"/>
+                  <a:srgbClr val="4338CA"/>
                 </a:solidFill>
                 <a:latin typeface="Segoe UI"/>
               </a:defRPr>
@@ -10680,7 +10680,7 @@
               </a:spcAft>
               <a:defRPr sz="2200" b="1">
                 <a:solidFill>
-                  <a:srgbClr val="FFFFFF"/>
+                  <a:srgbClr val="0F172A"/>
                 </a:solidFill>
                 <a:latin typeface="Segoe UI"/>
               </a:defRPr>
@@ -10693,7 +10693,7 @@
             <a:pPr>
               <a:defRPr sz="1300">
                 <a:solidFill>
-                  <a:srgbClr val="94A3B8"/>
+                  <a:srgbClr val="64748B"/>
                 </a:solidFill>
                 <a:latin typeface="Segoe UI"/>
               </a:defRPr>
@@ -10719,11 +10719,11 @@
             <a:avLst/>
           </a:prstGeom>
           <a:solidFill>
-            <a:srgbClr val="131B2E"/>
+            <a:srgbClr val="F8FAFC"/>
           </a:solidFill>
-          <a:ln w="12700">
+          <a:ln w="15240">
             <a:solidFill>
-              <a:srgbClr val="283554"/>
+              <a:srgbClr val="E2E8F0"/>
             </a:solidFill>
           </a:ln>
         </p:spPr>
@@ -10774,7 +10774,7 @@
             <a:pPr>
               <a:defRPr sz="1500" b="1">
                 <a:solidFill>
-                  <a:srgbClr val="06B6D4"/>
+                  <a:srgbClr val="0369A1"/>
                 </a:solidFill>
                 <a:latin typeface="Segoe UI"/>
               </a:defRPr>
@@ -10813,7 +10813,7 @@
               </a:spcAft>
               <a:defRPr sz="1300">
                 <a:solidFill>
-                  <a:srgbClr val="CBD5E1"/>
+                  <a:srgbClr val="334155"/>
                 </a:solidFill>
                 <a:latin typeface="Segoe UI"/>
               </a:defRPr>
@@ -10829,7 +10829,7 @@
               </a:spcAft>
               <a:defRPr sz="1300">
                 <a:solidFill>
-                  <a:srgbClr val="CBD5E1"/>
+                  <a:srgbClr val="334155"/>
                 </a:solidFill>
                 <a:latin typeface="Segoe UI"/>
               </a:defRPr>
@@ -10845,23 +10845,23 @@
               </a:spcAft>
               <a:defRPr sz="1300">
                 <a:solidFill>
-                  <a:srgbClr val="CBD5E1"/>
-                </a:solidFill>
-                <a:latin typeface="Segoe UI"/>
-              </a:defRPr>
-            </a:pPr>
-            <a:r>
-              <a:t>• TailwindCSS: Giao diện Dark Mode.</a:t>
-            </a:r>
-          </a:p>
-          <a:p>
-            <a:pPr>
-              <a:spcAft>
-                <a:spcPts val="700"/>
-              </a:spcAft>
-              <a:defRPr sz="1300">
-                <a:solidFill>
-                  <a:srgbClr val="CBD5E1"/>
+                  <a:srgbClr val="334155"/>
+                </a:solidFill>
+                <a:latin typeface="Segoe UI"/>
+              </a:defRPr>
+            </a:pPr>
+            <a:r>
+              <a:t>• TailwindCSS: UI hiện đại, responsive.</a:t>
+            </a:r>
+          </a:p>
+          <a:p>
+            <a:pPr>
+              <a:spcAft>
+                <a:spcPts val="700"/>
+              </a:spcAft>
+              <a:defRPr sz="1300">
+                <a:solidFill>
+                  <a:srgbClr val="334155"/>
                 </a:solidFill>
                 <a:latin typeface="Segoe UI"/>
               </a:defRPr>
@@ -10877,7 +10877,7 @@
               </a:spcAft>
               <a:defRPr sz="1300">
                 <a:solidFill>
-                  <a:srgbClr val="CBD5E1"/>
+                  <a:srgbClr val="334155"/>
                 </a:solidFill>
                 <a:latin typeface="Segoe UI"/>
               </a:defRPr>
@@ -10903,11 +10903,11 @@
             <a:avLst/>
           </a:prstGeom>
           <a:solidFill>
-            <a:srgbClr val="131B2E"/>
+            <a:srgbClr val="F8FAFC"/>
           </a:solidFill>
-          <a:ln w="12700">
+          <a:ln w="15240">
             <a:solidFill>
-              <a:srgbClr val="283554"/>
+              <a:srgbClr val="E2E8F0"/>
             </a:solidFill>
           </a:ln>
         </p:spPr>
@@ -10958,7 +10958,7 @@
             <a:pPr>
               <a:defRPr sz="1500" b="1">
                 <a:solidFill>
-                  <a:srgbClr val="6366F1"/>
+                  <a:srgbClr val="4338CA"/>
                 </a:solidFill>
                 <a:latin typeface="Segoe UI"/>
               </a:defRPr>
@@ -10997,7 +10997,7 @@
               </a:spcAft>
               <a:defRPr sz="1300">
                 <a:solidFill>
-                  <a:srgbClr val="CBD5E1"/>
+                  <a:srgbClr val="334155"/>
                 </a:solidFill>
                 <a:latin typeface="Segoe UI"/>
               </a:defRPr>
@@ -11013,7 +11013,7 @@
               </a:spcAft>
               <a:defRPr sz="1300">
                 <a:solidFill>
-                  <a:srgbClr val="CBD5E1"/>
+                  <a:srgbClr val="334155"/>
                 </a:solidFill>
                 <a:latin typeface="Segoe UI"/>
               </a:defRPr>
@@ -11029,7 +11029,7 @@
               </a:spcAft>
               <a:defRPr sz="1300">
                 <a:solidFill>
-                  <a:srgbClr val="CBD5E1"/>
+                  <a:srgbClr val="334155"/>
                 </a:solidFill>
                 <a:latin typeface="Segoe UI"/>
               </a:defRPr>
@@ -11045,7 +11045,7 @@
               </a:spcAft>
               <a:defRPr sz="1300">
                 <a:solidFill>
-                  <a:srgbClr val="CBD5E1"/>
+                  <a:srgbClr val="334155"/>
                 </a:solidFill>
                 <a:latin typeface="Segoe UI"/>
               </a:defRPr>
@@ -11061,7 +11061,7 @@
               </a:spcAft>
               <a:defRPr sz="1300">
                 <a:solidFill>
-                  <a:srgbClr val="CBD5E1"/>
+                  <a:srgbClr val="334155"/>
                 </a:solidFill>
                 <a:latin typeface="Segoe UI"/>
               </a:defRPr>
@@ -11087,11 +11087,11 @@
             <a:avLst/>
           </a:prstGeom>
           <a:solidFill>
-            <a:srgbClr val="131B2E"/>
+            <a:srgbClr val="F8FAFC"/>
           </a:solidFill>
-          <a:ln w="12700">
+          <a:ln w="15240">
             <a:solidFill>
-              <a:srgbClr val="283554"/>
+              <a:srgbClr val="E2E8F0"/>
             </a:solidFill>
           </a:ln>
         </p:spPr>
@@ -11142,7 +11142,7 @@
             <a:pPr>
               <a:defRPr sz="1500" b="1">
                 <a:solidFill>
-                  <a:srgbClr val="10B981"/>
+                  <a:srgbClr val="047857"/>
                 </a:solidFill>
                 <a:latin typeface="Segoe UI"/>
               </a:defRPr>
@@ -11181,7 +11181,7 @@
               </a:spcAft>
               <a:defRPr sz="1300">
                 <a:solidFill>
-                  <a:srgbClr val="CBD5E1"/>
+                  <a:srgbClr val="334155"/>
                 </a:solidFill>
                 <a:latin typeface="Segoe UI"/>
               </a:defRPr>
@@ -11197,7 +11197,7 @@
               </a:spcAft>
               <a:defRPr sz="1300">
                 <a:solidFill>
-                  <a:srgbClr val="CBD5E1"/>
+                  <a:srgbClr val="334155"/>
                 </a:solidFill>
                 <a:latin typeface="Segoe UI"/>
               </a:defRPr>
@@ -11213,7 +11213,7 @@
               </a:spcAft>
               <a:defRPr sz="1300">
                 <a:solidFill>
-                  <a:srgbClr val="CBD5E1"/>
+                  <a:srgbClr val="334155"/>
                 </a:solidFill>
                 <a:latin typeface="Segoe UI"/>
               </a:defRPr>
@@ -11229,7 +11229,7 @@
               </a:spcAft>
               <a:defRPr sz="1300">
                 <a:solidFill>
-                  <a:srgbClr val="CBD5E1"/>
+                  <a:srgbClr val="334155"/>
                 </a:solidFill>
                 <a:latin typeface="Segoe UI"/>
               </a:defRPr>
@@ -11245,7 +11245,7 @@
               </a:spcAft>
               <a:defRPr sz="1300">
                 <a:solidFill>
-                  <a:srgbClr val="CBD5E1"/>
+                  <a:srgbClr val="334155"/>
                 </a:solidFill>
                 <a:latin typeface="Segoe UI"/>
               </a:defRPr>
@@ -11289,7 +11289,7 @@
             <a:avLst/>
           </a:prstGeom>
           <a:solidFill>
-            <a:srgbClr val="0B0F19"/>
+            <a:srgbClr val="FFFFFF"/>
           </a:solidFill>
           <a:ln>
             <a:noFill/>
@@ -11332,7 +11332,7 @@
             <a:avLst/>
           </a:prstGeom>
           <a:solidFill>
-            <a:srgbClr val="6366F1"/>
+            <a:srgbClr val="4338CA"/>
           </a:solidFill>
           <a:ln>
             <a:noFill/>
@@ -11388,7 +11388,7 @@
               </a:spcAft>
               <a:defRPr sz="1100" b="1">
                 <a:solidFill>
-                  <a:srgbClr val="06B6D4"/>
+                  <a:srgbClr val="4338CA"/>
                 </a:solidFill>
                 <a:latin typeface="Segoe UI"/>
               </a:defRPr>
@@ -11404,7 +11404,7 @@
               </a:spcAft>
               <a:defRPr sz="2200" b="1">
                 <a:solidFill>
-                  <a:srgbClr val="FFFFFF"/>
+                  <a:srgbClr val="0F172A"/>
                 </a:solidFill>
                 <a:latin typeface="Segoe UI"/>
               </a:defRPr>
@@ -11417,7 +11417,7 @@
             <a:pPr>
               <a:defRPr sz="1300">
                 <a:solidFill>
-                  <a:srgbClr val="94A3B8"/>
+                  <a:srgbClr val="64748B"/>
                 </a:solidFill>
                 <a:latin typeface="Segoe UI"/>
               </a:defRPr>
@@ -11443,11 +11443,11 @@
             <a:avLst/>
           </a:prstGeom>
           <a:solidFill>
-            <a:srgbClr val="131B2E"/>
+            <a:srgbClr val="F8FAFC"/>
           </a:solidFill>
-          <a:ln w="12700">
+          <a:ln w="15240">
             <a:solidFill>
-              <a:srgbClr val="283554"/>
+              <a:srgbClr val="E2E8F0"/>
             </a:solidFill>
           </a:ln>
         </p:spPr>
@@ -11498,7 +11498,7 @@
             <a:pPr>
               <a:defRPr sz="1500" b="1">
                 <a:solidFill>
-                  <a:srgbClr val="06B6D4"/>
+                  <a:srgbClr val="0369A1"/>
                 </a:solidFill>
                 <a:latin typeface="Segoe UI"/>
               </a:defRPr>
@@ -11537,7 +11537,7 @@
               </a:spcAft>
               <a:defRPr sz="1300">
                 <a:solidFill>
-                  <a:srgbClr val="CBD5E1"/>
+                  <a:srgbClr val="334155"/>
                 </a:solidFill>
                 <a:latin typeface="Segoe UI"/>
               </a:defRPr>
@@ -11553,7 +11553,7 @@
               </a:spcAft>
               <a:defRPr sz="1300">
                 <a:solidFill>
-                  <a:srgbClr val="CBD5E1"/>
+                  <a:srgbClr val="334155"/>
                 </a:solidFill>
                 <a:latin typeface="Segoe UI"/>
               </a:defRPr>
@@ -11569,7 +11569,7 @@
               </a:spcAft>
               <a:defRPr sz="1300">
                 <a:solidFill>
-                  <a:srgbClr val="CBD5E1"/>
+                  <a:srgbClr val="334155"/>
                 </a:solidFill>
                 <a:latin typeface="Segoe UI"/>
               </a:defRPr>
@@ -11585,7 +11585,7 @@
               </a:spcAft>
               <a:defRPr sz="1300">
                 <a:solidFill>
-                  <a:srgbClr val="CBD5E1"/>
+                  <a:srgbClr val="334155"/>
                 </a:solidFill>
                 <a:latin typeface="Segoe UI"/>
               </a:defRPr>
@@ -11601,7 +11601,7 @@
               </a:spcAft>
               <a:defRPr sz="1300">
                 <a:solidFill>
-                  <a:srgbClr val="CBD5E1"/>
+                  <a:srgbClr val="334155"/>
                 </a:solidFill>
                 <a:latin typeface="Segoe UI"/>
               </a:defRPr>
@@ -11627,11 +11627,11 @@
             <a:avLst/>
           </a:prstGeom>
           <a:solidFill>
-            <a:srgbClr val="131B2E"/>
+            <a:srgbClr val="F8FAFC"/>
           </a:solidFill>
-          <a:ln w="12700">
+          <a:ln w="15240">
             <a:solidFill>
-              <a:srgbClr val="283554"/>
+              <a:srgbClr val="E2E8F0"/>
             </a:solidFill>
           </a:ln>
         </p:spPr>
@@ -11682,7 +11682,7 @@
             <a:pPr>
               <a:defRPr sz="1500" b="1">
                 <a:solidFill>
-                  <a:srgbClr val="6366F1"/>
+                  <a:srgbClr val="4338CA"/>
                 </a:solidFill>
                 <a:latin typeface="Segoe UI"/>
               </a:defRPr>
@@ -11721,7 +11721,7 @@
               </a:spcAft>
               <a:defRPr sz="1300">
                 <a:solidFill>
-                  <a:srgbClr val="CBD5E1"/>
+                  <a:srgbClr val="334155"/>
                 </a:solidFill>
                 <a:latin typeface="Segoe UI"/>
               </a:defRPr>
@@ -11737,7 +11737,7 @@
               </a:spcAft>
               <a:defRPr sz="1300">
                 <a:solidFill>
-                  <a:srgbClr val="CBD5E1"/>
+                  <a:srgbClr val="334155"/>
                 </a:solidFill>
                 <a:latin typeface="Segoe UI"/>
               </a:defRPr>
@@ -11753,7 +11753,7 @@
               </a:spcAft>
               <a:defRPr sz="1300">
                 <a:solidFill>
-                  <a:srgbClr val="CBD5E1"/>
+                  <a:srgbClr val="334155"/>
                 </a:solidFill>
                 <a:latin typeface="Segoe UI"/>
               </a:defRPr>
@@ -11769,7 +11769,7 @@
               </a:spcAft>
               <a:defRPr sz="1300">
                 <a:solidFill>
-                  <a:srgbClr val="CBD5E1"/>
+                  <a:srgbClr val="334155"/>
                 </a:solidFill>
                 <a:latin typeface="Segoe UI"/>
               </a:defRPr>
@@ -11785,7 +11785,7 @@
               </a:spcAft>
               <a:defRPr sz="1300">
                 <a:solidFill>
-                  <a:srgbClr val="CBD5E1"/>
+                  <a:srgbClr val="334155"/>
                 </a:solidFill>
                 <a:latin typeface="Segoe UI"/>
               </a:defRPr>
@@ -11811,11 +11811,11 @@
             <a:avLst/>
           </a:prstGeom>
           <a:solidFill>
-            <a:srgbClr val="131B2E"/>
+            <a:srgbClr val="F8FAFC"/>
           </a:solidFill>
-          <a:ln w="12700">
+          <a:ln w="15240">
             <a:solidFill>
-              <a:srgbClr val="283554"/>
+              <a:srgbClr val="E2E8F0"/>
             </a:solidFill>
           </a:ln>
         </p:spPr>
@@ -11866,7 +11866,7 @@
             <a:pPr>
               <a:defRPr sz="1500" b="1">
                 <a:solidFill>
-                  <a:srgbClr val="10B981"/>
+                  <a:srgbClr val="047857"/>
                 </a:solidFill>
                 <a:latin typeface="Segoe UI"/>
               </a:defRPr>
@@ -11905,7 +11905,7 @@
               </a:spcAft>
               <a:defRPr sz="1300">
                 <a:solidFill>
-                  <a:srgbClr val="CBD5E1"/>
+                  <a:srgbClr val="334155"/>
                 </a:solidFill>
                 <a:latin typeface="Segoe UI"/>
               </a:defRPr>
@@ -11921,7 +11921,7 @@
               </a:spcAft>
               <a:defRPr sz="1300">
                 <a:solidFill>
-                  <a:srgbClr val="CBD5E1"/>
+                  <a:srgbClr val="334155"/>
                 </a:solidFill>
                 <a:latin typeface="Segoe UI"/>
               </a:defRPr>
@@ -11937,7 +11937,7 @@
               </a:spcAft>
               <a:defRPr sz="1300">
                 <a:solidFill>
-                  <a:srgbClr val="CBD5E1"/>
+                  <a:srgbClr val="334155"/>
                 </a:solidFill>
                 <a:latin typeface="Segoe UI"/>
               </a:defRPr>
@@ -11953,7 +11953,7 @@
               </a:spcAft>
               <a:defRPr sz="1300">
                 <a:solidFill>
-                  <a:srgbClr val="CBD5E1"/>
+                  <a:srgbClr val="334155"/>
                 </a:solidFill>
                 <a:latin typeface="Segoe UI"/>
               </a:defRPr>
@@ -11969,7 +11969,7 @@
               </a:spcAft>
               <a:defRPr sz="1300">
                 <a:solidFill>
-                  <a:srgbClr val="CBD5E1"/>
+                  <a:srgbClr val="334155"/>
                 </a:solidFill>
                 <a:latin typeface="Segoe UI"/>
               </a:defRPr>
@@ -12013,7 +12013,7 @@
             <a:avLst/>
           </a:prstGeom>
           <a:solidFill>
-            <a:srgbClr val="0B0F19"/>
+            <a:srgbClr val="FFFFFF"/>
           </a:solidFill>
           <a:ln>
             <a:noFill/>
@@ -12056,7 +12056,7 @@
             <a:avLst/>
           </a:prstGeom>
           <a:solidFill>
-            <a:srgbClr val="6366F1"/>
+            <a:srgbClr val="4338CA"/>
           </a:solidFill>
           <a:ln>
             <a:noFill/>
@@ -12112,7 +12112,7 @@
               </a:spcAft>
               <a:defRPr sz="1100" b="1">
                 <a:solidFill>
-                  <a:srgbClr val="06B6D4"/>
+                  <a:srgbClr val="4338CA"/>
                 </a:solidFill>
                 <a:latin typeface="Segoe UI"/>
               </a:defRPr>
@@ -12128,7 +12128,7 @@
               </a:spcAft>
               <a:defRPr sz="2200" b="1">
                 <a:solidFill>
-                  <a:srgbClr val="FFFFFF"/>
+                  <a:srgbClr val="0F172A"/>
                 </a:solidFill>
                 <a:latin typeface="Segoe UI"/>
               </a:defRPr>
@@ -12141,7 +12141,7 @@
             <a:pPr>
               <a:defRPr sz="1300">
                 <a:solidFill>
-                  <a:srgbClr val="94A3B8"/>
+                  <a:srgbClr val="64748B"/>
                 </a:solidFill>
                 <a:latin typeface="Segoe UI"/>
               </a:defRPr>
@@ -12167,11 +12167,11 @@
             <a:avLst/>
           </a:prstGeom>
           <a:solidFill>
-            <a:srgbClr val="131B2E"/>
+            <a:srgbClr val="F8FAFC"/>
           </a:solidFill>
-          <a:ln w="12700">
+          <a:ln w="15240">
             <a:solidFill>
-              <a:srgbClr val="283554"/>
+              <a:srgbClr val="E2E8F0"/>
             </a:solidFill>
           </a:ln>
         </p:spPr>
@@ -12222,7 +12222,7 @@
             <a:pPr>
               <a:defRPr sz="1500" b="1">
                 <a:solidFill>
-                  <a:srgbClr val="06B6D4"/>
+                  <a:srgbClr val="0369A1"/>
                 </a:solidFill>
                 <a:latin typeface="Segoe UI"/>
               </a:defRPr>
@@ -12261,7 +12261,7 @@
               </a:spcAft>
               <a:defRPr sz="1300">
                 <a:solidFill>
-                  <a:srgbClr val="CBD5E1"/>
+                  <a:srgbClr val="334155"/>
                 </a:solidFill>
                 <a:latin typeface="Segoe UI"/>
               </a:defRPr>
@@ -12277,7 +12277,7 @@
               </a:spcAft>
               <a:defRPr sz="1300">
                 <a:solidFill>
-                  <a:srgbClr val="CBD5E1"/>
+                  <a:srgbClr val="334155"/>
                 </a:solidFill>
                 <a:latin typeface="Segoe UI"/>
               </a:defRPr>
@@ -12293,7 +12293,7 @@
               </a:spcAft>
               <a:defRPr sz="1300">
                 <a:solidFill>
-                  <a:srgbClr val="CBD5E1"/>
+                  <a:srgbClr val="334155"/>
                 </a:solidFill>
                 <a:latin typeface="Segoe UI"/>
               </a:defRPr>
@@ -12309,7 +12309,7 @@
               </a:spcAft>
               <a:defRPr sz="1300">
                 <a:solidFill>
-                  <a:srgbClr val="CBD5E1"/>
+                  <a:srgbClr val="334155"/>
                 </a:solidFill>
                 <a:latin typeface="Segoe UI"/>
               </a:defRPr>
@@ -12325,7 +12325,7 @@
               </a:spcAft>
               <a:defRPr sz="1300">
                 <a:solidFill>
-                  <a:srgbClr val="CBD5E1"/>
+                  <a:srgbClr val="334155"/>
                 </a:solidFill>
                 <a:latin typeface="Segoe UI"/>
               </a:defRPr>
@@ -12351,11 +12351,11 @@
             <a:avLst/>
           </a:prstGeom>
           <a:solidFill>
-            <a:srgbClr val="131B2E"/>
+            <a:srgbClr val="F8FAFC"/>
           </a:solidFill>
-          <a:ln w="12700">
+          <a:ln w="15240">
             <a:solidFill>
-              <a:srgbClr val="283554"/>
+              <a:srgbClr val="E2E8F0"/>
             </a:solidFill>
           </a:ln>
         </p:spPr>
@@ -12406,7 +12406,7 @@
             <a:pPr>
               <a:defRPr sz="1500" b="1">
                 <a:solidFill>
-                  <a:srgbClr val="10B981"/>
+                  <a:srgbClr val="047857"/>
                 </a:solidFill>
                 <a:latin typeface="Segoe UI"/>
               </a:defRPr>
@@ -12445,7 +12445,7 @@
               </a:spcAft>
               <a:defRPr sz="1300">
                 <a:solidFill>
-                  <a:srgbClr val="CBD5E1"/>
+                  <a:srgbClr val="334155"/>
                 </a:solidFill>
                 <a:latin typeface="Segoe UI"/>
               </a:defRPr>
@@ -12461,7 +12461,7 @@
               </a:spcAft>
               <a:defRPr sz="1300">
                 <a:solidFill>
-                  <a:srgbClr val="CBD5E1"/>
+                  <a:srgbClr val="334155"/>
                 </a:solidFill>
                 <a:latin typeface="Segoe UI"/>
               </a:defRPr>
@@ -12477,7 +12477,7 @@
               </a:spcAft>
               <a:defRPr sz="1300">
                 <a:solidFill>
-                  <a:srgbClr val="CBD5E1"/>
+                  <a:srgbClr val="334155"/>
                 </a:solidFill>
                 <a:latin typeface="Segoe UI"/>
               </a:defRPr>
@@ -12493,7 +12493,7 @@
               </a:spcAft>
               <a:defRPr sz="1300">
                 <a:solidFill>
-                  <a:srgbClr val="CBD5E1"/>
+                  <a:srgbClr val="334155"/>
                 </a:solidFill>
                 <a:latin typeface="Segoe UI"/>
               </a:defRPr>
@@ -12509,7 +12509,7 @@
               </a:spcAft>
               <a:defRPr sz="1300">
                 <a:solidFill>
-                  <a:srgbClr val="CBD5E1"/>
+                  <a:srgbClr val="334155"/>
                 </a:solidFill>
                 <a:latin typeface="Segoe UI"/>
               </a:defRPr>
@@ -12553,7 +12553,7 @@
             <a:avLst/>
           </a:prstGeom>
           <a:solidFill>
-            <a:srgbClr val="0B0F19"/>
+            <a:srgbClr val="FFFFFF"/>
           </a:solidFill>
           <a:ln>
             <a:noFill/>
@@ -12596,7 +12596,7 @@
             <a:avLst/>
           </a:prstGeom>
           <a:solidFill>
-            <a:srgbClr val="6366F1"/>
+            <a:srgbClr val="4338CA"/>
           </a:solidFill>
           <a:ln>
             <a:noFill/>
@@ -12652,7 +12652,7 @@
               </a:spcAft>
               <a:defRPr sz="1100" b="1">
                 <a:solidFill>
-                  <a:srgbClr val="06B6D4"/>
+                  <a:srgbClr val="4338CA"/>
                 </a:solidFill>
                 <a:latin typeface="Segoe UI"/>
               </a:defRPr>
@@ -12668,7 +12668,7 @@
               </a:spcAft>
               <a:defRPr sz="2200" b="1">
                 <a:solidFill>
-                  <a:srgbClr val="FFFFFF"/>
+                  <a:srgbClr val="0F172A"/>
                 </a:solidFill>
                 <a:latin typeface="Segoe UI"/>
               </a:defRPr>
@@ -12681,7 +12681,7 @@
             <a:pPr>
               <a:defRPr sz="1300">
                 <a:solidFill>
-                  <a:srgbClr val="94A3B8"/>
+                  <a:srgbClr val="64748B"/>
                 </a:solidFill>
                 <a:latin typeface="Segoe UI"/>
               </a:defRPr>
@@ -12707,11 +12707,11 @@
             <a:avLst/>
           </a:prstGeom>
           <a:solidFill>
-            <a:srgbClr val="131B2E"/>
+            <a:srgbClr val="F8FAFC"/>
           </a:solidFill>
-          <a:ln w="12700">
+          <a:ln w="15240">
             <a:solidFill>
-              <a:srgbClr val="283554"/>
+              <a:srgbClr val="E2E8F0"/>
             </a:solidFill>
           </a:ln>
         </p:spPr>
@@ -12762,7 +12762,7 @@
             <a:pPr>
               <a:defRPr sz="1500" b="1">
                 <a:solidFill>
-                  <a:srgbClr val="F59E0B"/>
+                  <a:srgbClr val="B45309"/>
                 </a:solidFill>
                 <a:latin typeface="Segoe UI"/>
               </a:defRPr>
@@ -12801,7 +12801,7 @@
               </a:spcAft>
               <a:defRPr sz="1300">
                 <a:solidFill>
-                  <a:srgbClr val="CBD5E1"/>
+                  <a:srgbClr val="334155"/>
                 </a:solidFill>
                 <a:latin typeface="Segoe UI"/>
               </a:defRPr>
@@ -12817,7 +12817,7 @@
               </a:spcAft>
               <a:defRPr sz="1300">
                 <a:solidFill>
-                  <a:srgbClr val="CBD5E1"/>
+                  <a:srgbClr val="334155"/>
                 </a:solidFill>
                 <a:latin typeface="Segoe UI"/>
               </a:defRPr>
@@ -12833,7 +12833,7 @@
               </a:spcAft>
               <a:defRPr sz="1300">
                 <a:solidFill>
-                  <a:srgbClr val="CBD5E1"/>
+                  <a:srgbClr val="334155"/>
                 </a:solidFill>
                 <a:latin typeface="Segoe UI"/>
               </a:defRPr>
@@ -12849,7 +12849,7 @@
               </a:spcAft>
               <a:defRPr sz="1300">
                 <a:solidFill>
-                  <a:srgbClr val="CBD5E1"/>
+                  <a:srgbClr val="334155"/>
                 </a:solidFill>
                 <a:latin typeface="Segoe UI"/>
               </a:defRPr>
@@ -12865,7 +12865,7 @@
               </a:spcAft>
               <a:defRPr sz="1300">
                 <a:solidFill>
-                  <a:srgbClr val="CBD5E1"/>
+                  <a:srgbClr val="334155"/>
                 </a:solidFill>
                 <a:latin typeface="Segoe UI"/>
               </a:defRPr>
@@ -12891,11 +12891,11 @@
             <a:avLst/>
           </a:prstGeom>
           <a:solidFill>
-            <a:srgbClr val="131B2E"/>
+            <a:srgbClr val="F8FAFC"/>
           </a:solidFill>
-          <a:ln w="12700">
+          <a:ln w="15240">
             <a:solidFill>
-              <a:srgbClr val="283554"/>
+              <a:srgbClr val="E2E8F0"/>
             </a:solidFill>
           </a:ln>
         </p:spPr>
@@ -12946,7 +12946,7 @@
             <a:pPr>
               <a:defRPr sz="1500" b="1">
                 <a:solidFill>
-                  <a:srgbClr val="10B981"/>
+                  <a:srgbClr val="047857"/>
                 </a:solidFill>
                 <a:latin typeface="Segoe UI"/>
               </a:defRPr>
@@ -12985,7 +12985,7 @@
               </a:spcAft>
               <a:defRPr sz="1300">
                 <a:solidFill>
-                  <a:srgbClr val="CBD5E1"/>
+                  <a:srgbClr val="334155"/>
                 </a:solidFill>
                 <a:latin typeface="Segoe UI"/>
               </a:defRPr>
@@ -13001,7 +13001,7 @@
               </a:spcAft>
               <a:defRPr sz="1300">
                 <a:solidFill>
-                  <a:srgbClr val="CBD5E1"/>
+                  <a:srgbClr val="334155"/>
                 </a:solidFill>
                 <a:latin typeface="Segoe UI"/>
               </a:defRPr>
@@ -13017,7 +13017,7 @@
               </a:spcAft>
               <a:defRPr sz="1300">
                 <a:solidFill>
-                  <a:srgbClr val="CBD5E1"/>
+                  <a:srgbClr val="334155"/>
                 </a:solidFill>
                 <a:latin typeface="Segoe UI"/>
               </a:defRPr>
@@ -13033,7 +13033,7 @@
               </a:spcAft>
               <a:defRPr sz="1300">
                 <a:solidFill>
-                  <a:srgbClr val="CBD5E1"/>
+                  <a:srgbClr val="334155"/>
                 </a:solidFill>
                 <a:latin typeface="Segoe UI"/>
               </a:defRPr>
@@ -13049,7 +13049,7 @@
               </a:spcAft>
               <a:defRPr sz="1300">
                 <a:solidFill>
-                  <a:srgbClr val="CBD5E1"/>
+                  <a:srgbClr val="334155"/>
                 </a:solidFill>
                 <a:latin typeface="Segoe UI"/>
               </a:defRPr>

</xml_diff>